<commit_message>
Update DSS_2026_Tutorial PDF and PPTX presentation files.
</commit_message>
<xml_diff>
--- a/conf/DSS_20260618/presentation/pptx/DSS_2026_Tutorial.pptx
+++ b/conf/DSS_20260618/presentation/pptx/DSS_2026_Tutorial.pptx
@@ -90,7 +90,7 @@
         <p:txBody>
           <a:bodyPr/>
           <a:p>
-            <a:fld id="{F87F9A81-F035-4C61-ABFA-22393BABF1FE}" type="slidenum">
+            <a:fld id="{84E71060-E972-4C2D-AB26-F6869C246E70}" type="slidenum">
               <a:t>&lt;#&gt;</a:t>
             </a:fld>
           </a:p>
@@ -278,7 +278,7 @@
         <p:txBody>
           <a:bodyPr/>
           <a:p>
-            <a:fld id="{1435677F-853C-41EF-8453-1DD42EC66ACC}" type="slidenum">
+            <a:fld id="{ABA444B5-F50B-4494-A345-F01D17D7D796}" type="slidenum">
               <a:t>&lt;#&gt;</a:t>
             </a:fld>
           </a:p>
@@ -534,7 +534,7 @@
         <p:txBody>
           <a:bodyPr/>
           <a:p>
-            <a:fld id="{8E78B32B-8E32-4AFB-BD33-FCE5DF63E1EB}" type="slidenum">
+            <a:fld id="{88716AE6-D6D9-468B-ACA1-541CD2573BF6}" type="slidenum">
               <a:t>&lt;#&gt;</a:t>
             </a:fld>
           </a:p>
@@ -858,7 +858,7 @@
         <p:txBody>
           <a:bodyPr/>
           <a:p>
-            <a:fld id="{BE5762A2-A5A1-4F90-801C-D2873A6E96F2}" type="slidenum">
+            <a:fld id="{65384249-6640-49BA-A7AD-2648AAE19EDA}" type="slidenum">
               <a:t>&lt;#&gt;</a:t>
             </a:fld>
           </a:p>
@@ -1015,7 +1015,7 @@
         <p:txBody>
           <a:bodyPr/>
           <a:p>
-            <a:fld id="{28E15D07-8E73-47BB-BE08-E76FD806D778}" type="slidenum">
+            <a:fld id="{75D190B6-F4F6-4018-91FD-0A27EE0FCE97}" type="slidenum">
               <a:t>&lt;#&gt;</a:t>
             </a:fld>
           </a:p>
@@ -1169,7 +1169,7 @@
         <p:txBody>
           <a:bodyPr/>
           <a:p>
-            <a:fld id="{D47453A2-7C75-4F31-8C7F-4B6833B8746C}" type="slidenum">
+            <a:fld id="{26F2CD7C-3605-459A-9099-E702E945192C}" type="slidenum">
               <a:t>&lt;#&gt;</a:t>
             </a:fld>
           </a:p>
@@ -1357,7 +1357,7 @@
         <p:txBody>
           <a:bodyPr/>
           <a:p>
-            <a:fld id="{FB86A9CC-5A0D-46A7-90D7-DEC863035CDB}" type="slidenum">
+            <a:fld id="{A4433EBD-8CDE-440B-8F24-63BB750F1E02}" type="slidenum">
               <a:t>&lt;#&gt;</a:t>
             </a:fld>
           </a:p>
@@ -1477,7 +1477,7 @@
         <p:txBody>
           <a:bodyPr/>
           <a:p>
-            <a:fld id="{BAF0B5DD-EB9F-40E9-A26F-69F27895D15E}" type="slidenum">
+            <a:fld id="{617199EB-1F4C-414A-9857-4D1C2F55097B}" type="slidenum">
               <a:t>&lt;#&gt;</a:t>
             </a:fld>
           </a:p>
@@ -1597,7 +1597,7 @@
         <p:txBody>
           <a:bodyPr/>
           <a:p>
-            <a:fld id="{7F4951E1-D6F5-4471-8D35-E29893B2AB23}" type="slidenum">
+            <a:fld id="{543677C7-E803-4061-8295-7A138FDFACD5}" type="slidenum">
               <a:t>&lt;#&gt;</a:t>
             </a:fld>
           </a:p>
@@ -1819,7 +1819,7 @@
         <p:txBody>
           <a:bodyPr/>
           <a:p>
-            <a:fld id="{E655AECB-245B-4B36-8FBA-40B8DE5DECC4}" type="slidenum">
+            <a:fld id="{3C1035F7-23F2-40B3-BC04-5DB19B15F6F1}" type="slidenum">
               <a:t>&lt;#&gt;</a:t>
             </a:fld>
           </a:p>
@@ -2041,7 +2041,7 @@
         <p:txBody>
           <a:bodyPr/>
           <a:p>
-            <a:fld id="{C1CEB98D-8414-4749-8792-8DDB3867598F}" type="slidenum">
+            <a:fld id="{EB135158-3ED6-4D5E-BFFA-2BEB24E12A0B}" type="slidenum">
               <a:t>&lt;#&gt;</a:t>
             </a:fld>
           </a:p>
@@ -2263,7 +2263,7 @@
         <p:txBody>
           <a:bodyPr/>
           <a:p>
-            <a:fld id="{A2DF1B2E-3000-40DA-AEC5-FE1E111A49FC}" type="slidenum">
+            <a:fld id="{29A51D1C-E52F-4ECD-86A7-6EF4889047EE}" type="slidenum">
               <a:t>&lt;#&gt;</a:t>
             </a:fld>
           </a:p>
@@ -2332,7 +2332,7 @@
         <p:spPr>
           <a:xfrm>
             <a:off x="3124080" y="6356520"/>
-            <a:ext cx="2893320" cy="362880"/>
+            <a:ext cx="2892960" cy="362520"/>
           </a:xfrm>
           <a:prstGeom prst="rect">
             <a:avLst/>
@@ -2389,7 +2389,7 @@
         <p:spPr>
           <a:xfrm>
             <a:off x="6553080" y="6356520"/>
-            <a:ext cx="2131560" cy="362880"/>
+            <a:ext cx="2131200" cy="362520"/>
           </a:xfrm>
           <a:prstGeom prst="rect">
             <a:avLst/>
@@ -2424,7 +2424,7 @@
               </a:lnSpc>
               <a:buNone/>
             </a:pPr>
-            <a:fld id="{7AAAF06A-4272-4869-8A0C-CF2B1BDC071B}" type="slidenum">
+            <a:fld id="{A9D3A044-7160-4471-BFC5-F301D059CF9D}" type="slidenum">
               <a:rPr b="0" lang="en-US" sz="1200" spc="-1" strike="noStrike">
                 <a:solidFill>
                   <a:srgbClr val="8b8b8b"/>
@@ -2452,7 +2452,7 @@
         <p:spPr>
           <a:xfrm>
             <a:off x="457200" y="6356520"/>
-            <a:ext cx="2131560" cy="362880"/>
+            <a:ext cx="2131200" cy="362520"/>
           </a:xfrm>
           <a:prstGeom prst="rect">
             <a:avLst/>
@@ -2521,7 +2521,37 @@
               <a:rPr b="0" lang="pl-PL" sz="4400" spc="-1" strike="noStrike">
                 <a:latin typeface="Arial"/>
               </a:rPr>
-              <a:t>Kliknij, aby edytować format tekstu tytułu</a:t>
+              <a:t>Kliknij, </a:t>
+            </a:r>
+            <a:r>
+              <a:rPr b="0" lang="pl-PL" sz="4400" spc="-1" strike="noStrike">
+                <a:latin typeface="Arial"/>
+              </a:rPr>
+              <a:t>aby </a:t>
+            </a:r>
+            <a:r>
+              <a:rPr b="0" lang="pl-PL" sz="4400" spc="-1" strike="noStrike">
+                <a:latin typeface="Arial"/>
+              </a:rPr>
+              <a:t>edytować </a:t>
+            </a:r>
+            <a:r>
+              <a:rPr b="0" lang="pl-PL" sz="4400" spc="-1" strike="noStrike">
+                <a:latin typeface="Arial"/>
+              </a:rPr>
+              <a:t>format </a:t>
+            </a:r>
+            <a:r>
+              <a:rPr b="0" lang="pl-PL" sz="4400" spc="-1" strike="noStrike">
+                <a:latin typeface="Arial"/>
+              </a:rPr>
+              <a:t>tekstu </a:t>
+            </a:r>
+            <a:r>
+              <a:rPr b="0" lang="pl-PL" sz="4400" spc="-1" strike="noStrike">
+                <a:latin typeface="Arial"/>
+              </a:rPr>
+              <a:t>tytułu</a:t>
             </a:r>
             <a:endParaRPr b="0" lang="pl-PL" sz="4400" spc="-1" strike="noStrike">
               <a:latin typeface="Arial"/>
@@ -2765,7 +2795,7 @@
         <p:spPr>
           <a:xfrm>
             <a:off x="0" y="2331720"/>
-            <a:ext cx="1826640" cy="61200"/>
+            <a:ext cx="1826280" cy="60840"/>
           </a:xfrm>
           <a:prstGeom prst="rect">
             <a:avLst/>
@@ -2806,7 +2836,7 @@
         <p:spPr>
           <a:xfrm>
             <a:off x="768240" y="868680"/>
-            <a:ext cx="2283840" cy="212760"/>
+            <a:ext cx="2283480" cy="212760"/>
           </a:xfrm>
           <a:prstGeom prst="rect">
             <a:avLst/>
@@ -2858,7 +2888,7 @@
         <p:spPr>
           <a:xfrm>
             <a:off x="768240" y="2514600"/>
-            <a:ext cx="10422000" cy="1471320"/>
+            <a:ext cx="10421640" cy="1471320"/>
           </a:xfrm>
           <a:prstGeom prst="rect">
             <a:avLst/>
@@ -2931,7 +2961,7 @@
         <p:spPr>
           <a:xfrm>
             <a:off x="768240" y="4343400"/>
-            <a:ext cx="10056240" cy="630360"/>
+            <a:ext cx="10055880" cy="630360"/>
           </a:xfrm>
           <a:prstGeom prst="rect">
             <a:avLst/>
@@ -2983,7 +3013,7 @@
         <p:spPr>
           <a:xfrm>
             <a:off x="768240" y="5623560"/>
-            <a:ext cx="7313040" cy="486360"/>
+            <a:ext cx="7312680" cy="486360"/>
           </a:xfrm>
           <a:prstGeom prst="rect">
             <a:avLst/>
@@ -3060,7 +3090,7 @@
         <p:spPr>
           <a:xfrm>
             <a:off x="10983960" y="6336000"/>
-            <a:ext cx="1061280" cy="596520"/>
+            <a:ext cx="1060920" cy="596160"/>
           </a:xfrm>
           <a:prstGeom prst="rect">
             <a:avLst/>
@@ -3116,7 +3146,7 @@
         <p:spPr>
           <a:xfrm>
             <a:off x="768240" y="420480"/>
-            <a:ext cx="10604880" cy="441360"/>
+            <a:ext cx="10604520" cy="441360"/>
           </a:xfrm>
           <a:prstGeom prst="rect">
             <a:avLst/>
@@ -3168,7 +3198,7 @@
         <p:spPr>
           <a:xfrm>
             <a:off x="768240" y="1170360"/>
-            <a:ext cx="1369440" cy="42120"/>
+            <a:ext cx="1369080" cy="41760"/>
           </a:xfrm>
           <a:prstGeom prst="rect">
             <a:avLst/>
@@ -3209,7 +3239,7 @@
         <p:spPr>
           <a:xfrm>
             <a:off x="768240" y="1298520"/>
-            <a:ext cx="10604880" cy="227880"/>
+            <a:ext cx="10604520" cy="227880"/>
           </a:xfrm>
           <a:prstGeom prst="rect">
             <a:avLst/>
@@ -3261,7 +3291,7 @@
         <p:spPr>
           <a:xfrm>
             <a:off x="0" y="6437520"/>
-            <a:ext cx="12189600" cy="12960"/>
+            <a:ext cx="12189240" cy="12600"/>
           </a:xfrm>
           <a:prstGeom prst="rect">
             <a:avLst/>
@@ -3302,7 +3332,7 @@
         <p:spPr>
           <a:xfrm>
             <a:off x="768240" y="6473880"/>
-            <a:ext cx="8227440" cy="136800"/>
+            <a:ext cx="8227080" cy="136800"/>
           </a:xfrm>
           <a:prstGeom prst="rect">
             <a:avLst/>
@@ -3354,7 +3384,7 @@
         <p:spPr>
           <a:xfrm>
             <a:off x="10607040" y="6473880"/>
-            <a:ext cx="820800" cy="136800"/>
+            <a:ext cx="820440" cy="136800"/>
           </a:xfrm>
           <a:prstGeom prst="rect">
             <a:avLst/>
@@ -3406,7 +3436,7 @@
         <p:spPr>
           <a:xfrm>
             <a:off x="768240" y="1828800"/>
-            <a:ext cx="5027040" cy="1460880"/>
+            <a:ext cx="5026680" cy="1460520"/>
           </a:xfrm>
           <a:prstGeom prst="roundRect">
             <a:avLst>
@@ -3449,7 +3479,7 @@
         <p:spPr>
           <a:xfrm>
             <a:off x="768240" y="1828800"/>
-            <a:ext cx="48600" cy="1460880"/>
+            <a:ext cx="48240" cy="1460520"/>
           </a:xfrm>
           <a:prstGeom prst="rect">
             <a:avLst/>
@@ -3490,7 +3520,7 @@
         <p:spPr>
           <a:xfrm>
             <a:off x="1042560" y="1993320"/>
-            <a:ext cx="4569840" cy="243000"/>
+            <a:ext cx="4569480" cy="243000"/>
           </a:xfrm>
           <a:prstGeom prst="rect">
             <a:avLst/>
@@ -3542,7 +3572,7 @@
         <p:spPr>
           <a:xfrm>
             <a:off x="1042560" y="2423160"/>
-            <a:ext cx="4569840" cy="435240"/>
+            <a:ext cx="4569480" cy="435240"/>
           </a:xfrm>
           <a:prstGeom prst="rect">
             <a:avLst/>
@@ -3594,7 +3624,7 @@
         <p:spPr>
           <a:xfrm>
             <a:off x="6400800" y="1828800"/>
-            <a:ext cx="5027040" cy="1460880"/>
+            <a:ext cx="5026680" cy="1460520"/>
           </a:xfrm>
           <a:prstGeom prst="roundRect">
             <a:avLst>
@@ -3637,7 +3667,7 @@
         <p:spPr>
           <a:xfrm>
             <a:off x="6400800" y="1828800"/>
-            <a:ext cx="48600" cy="1460880"/>
+            <a:ext cx="48240" cy="1460520"/>
           </a:xfrm>
           <a:prstGeom prst="rect">
             <a:avLst/>
@@ -3678,7 +3708,7 @@
         <p:spPr>
           <a:xfrm>
             <a:off x="6675120" y="1993320"/>
-            <a:ext cx="4569840" cy="243000"/>
+            <a:ext cx="4569480" cy="243000"/>
           </a:xfrm>
           <a:prstGeom prst="rect">
             <a:avLst/>
@@ -3730,7 +3760,7 @@
         <p:spPr>
           <a:xfrm>
             <a:off x="6675120" y="2423160"/>
-            <a:ext cx="4569840" cy="435240"/>
+            <a:ext cx="4569480" cy="435240"/>
           </a:xfrm>
           <a:prstGeom prst="rect">
             <a:avLst/>
@@ -3782,7 +3812,7 @@
         <p:spPr>
           <a:xfrm>
             <a:off x="768240" y="3566160"/>
-            <a:ext cx="5027040" cy="1460880"/>
+            <a:ext cx="5026680" cy="1460520"/>
           </a:xfrm>
           <a:prstGeom prst="roundRect">
             <a:avLst>
@@ -3825,7 +3855,7 @@
         <p:spPr>
           <a:xfrm>
             <a:off x="768240" y="3566160"/>
-            <a:ext cx="48600" cy="1460880"/>
+            <a:ext cx="48240" cy="1460520"/>
           </a:xfrm>
           <a:prstGeom prst="rect">
             <a:avLst/>
@@ -3866,7 +3896,7 @@
         <p:spPr>
           <a:xfrm>
             <a:off x="1042560" y="3730680"/>
-            <a:ext cx="4569840" cy="243000"/>
+            <a:ext cx="4569480" cy="243000"/>
           </a:xfrm>
           <a:prstGeom prst="rect">
             <a:avLst/>
@@ -3918,7 +3948,7 @@
         <p:spPr>
           <a:xfrm>
             <a:off x="1042560" y="4160520"/>
-            <a:ext cx="4569840" cy="217440"/>
+            <a:ext cx="4569480" cy="217440"/>
           </a:xfrm>
           <a:prstGeom prst="rect">
             <a:avLst/>
@@ -3970,7 +4000,7 @@
         <p:spPr>
           <a:xfrm>
             <a:off x="6400800" y="3566160"/>
-            <a:ext cx="5027040" cy="1460880"/>
+            <a:ext cx="5026680" cy="1460520"/>
           </a:xfrm>
           <a:prstGeom prst="roundRect">
             <a:avLst>
@@ -4013,7 +4043,7 @@
         <p:spPr>
           <a:xfrm>
             <a:off x="6400800" y="3566160"/>
-            <a:ext cx="48600" cy="1460880"/>
+            <a:ext cx="48240" cy="1460520"/>
           </a:xfrm>
           <a:prstGeom prst="rect">
             <a:avLst/>
@@ -4054,7 +4084,7 @@
         <p:spPr>
           <a:xfrm>
             <a:off x="6675120" y="3730680"/>
-            <a:ext cx="4569840" cy="243000"/>
+            <a:ext cx="4569480" cy="243000"/>
           </a:xfrm>
           <a:prstGeom prst="rect">
             <a:avLst/>
@@ -4106,7 +4136,7 @@
         <p:spPr>
           <a:xfrm>
             <a:off x="6675120" y="4160520"/>
-            <a:ext cx="4569840" cy="217440"/>
+            <a:ext cx="4569480" cy="217440"/>
           </a:xfrm>
           <a:prstGeom prst="rect">
             <a:avLst/>
@@ -4195,7 +4225,7 @@
         <p:spPr>
           <a:xfrm>
             <a:off x="768240" y="420480"/>
-            <a:ext cx="10604880" cy="441360"/>
+            <a:ext cx="10604520" cy="441360"/>
           </a:xfrm>
           <a:prstGeom prst="rect">
             <a:avLst/>
@@ -4247,7 +4277,7 @@
         <p:spPr>
           <a:xfrm>
             <a:off x="768240" y="1170360"/>
-            <a:ext cx="1369440" cy="42120"/>
+            <a:ext cx="1369080" cy="41760"/>
           </a:xfrm>
           <a:prstGeom prst="rect">
             <a:avLst/>
@@ -4288,7 +4318,7 @@
         <p:spPr>
           <a:xfrm>
             <a:off x="0" y="6437520"/>
-            <a:ext cx="12189600" cy="12960"/>
+            <a:ext cx="12189240" cy="12600"/>
           </a:xfrm>
           <a:prstGeom prst="rect">
             <a:avLst/>
@@ -4329,7 +4359,7 @@
         <p:spPr>
           <a:xfrm>
             <a:off x="768240" y="6473880"/>
-            <a:ext cx="8227440" cy="136800"/>
+            <a:ext cx="8227080" cy="136800"/>
           </a:xfrm>
           <a:prstGeom prst="rect">
             <a:avLst/>
@@ -4381,7 +4411,7 @@
         <p:spPr>
           <a:xfrm>
             <a:off x="10607040" y="6473880"/>
-            <a:ext cx="820800" cy="136800"/>
+            <a:ext cx="820440" cy="136800"/>
           </a:xfrm>
           <a:prstGeom prst="rect">
             <a:avLst/>
@@ -4433,7 +4463,7 @@
         <p:spPr>
           <a:xfrm>
             <a:off x="768240" y="1417320"/>
-            <a:ext cx="3381120" cy="1186560"/>
+            <a:ext cx="3380760" cy="1186200"/>
           </a:xfrm>
           <a:prstGeom prst="roundRect">
             <a:avLst>
@@ -4476,7 +4506,7 @@
         <p:spPr>
           <a:xfrm>
             <a:off x="768240" y="1417320"/>
-            <a:ext cx="3381120" cy="455040"/>
+            <a:ext cx="3380760" cy="454680"/>
           </a:xfrm>
           <a:prstGeom prst="roundRect">
             <a:avLst>
@@ -4519,7 +4549,7 @@
         <p:spPr>
           <a:xfrm>
             <a:off x="768240" y="1481400"/>
-            <a:ext cx="3381120" cy="212760"/>
+            <a:ext cx="3380760" cy="212760"/>
           </a:xfrm>
           <a:prstGeom prst="rect">
             <a:avLst/>
@@ -4571,7 +4601,7 @@
         <p:spPr>
           <a:xfrm>
             <a:off x="951120" y="2011680"/>
-            <a:ext cx="3015360" cy="197640"/>
+            <a:ext cx="3015000" cy="197640"/>
           </a:xfrm>
           <a:prstGeom prst="rect">
             <a:avLst/>
@@ -4623,7 +4653,7 @@
         <p:spPr>
           <a:xfrm>
             <a:off x="4380120" y="1417320"/>
-            <a:ext cx="3381120" cy="1186560"/>
+            <a:ext cx="3380760" cy="1186200"/>
           </a:xfrm>
           <a:prstGeom prst="roundRect">
             <a:avLst>
@@ -4666,7 +4696,7 @@
         <p:spPr>
           <a:xfrm>
             <a:off x="4380120" y="1417320"/>
-            <a:ext cx="3381120" cy="455040"/>
+            <a:ext cx="3380760" cy="454680"/>
           </a:xfrm>
           <a:prstGeom prst="roundRect">
             <a:avLst>
@@ -4709,7 +4739,7 @@
         <p:spPr>
           <a:xfrm>
             <a:off x="4380120" y="1481400"/>
-            <a:ext cx="3381120" cy="212760"/>
+            <a:ext cx="3380760" cy="212760"/>
           </a:xfrm>
           <a:prstGeom prst="rect">
             <a:avLst/>
@@ -4761,7 +4791,7 @@
         <p:spPr>
           <a:xfrm>
             <a:off x="4563000" y="2011680"/>
-            <a:ext cx="3015360" cy="197640"/>
+            <a:ext cx="3015000" cy="197640"/>
           </a:xfrm>
           <a:prstGeom prst="rect">
             <a:avLst/>
@@ -4813,7 +4843,7 @@
         <p:spPr>
           <a:xfrm>
             <a:off x="7992000" y="1417320"/>
-            <a:ext cx="3381120" cy="1186560"/>
+            <a:ext cx="3380760" cy="1186200"/>
           </a:xfrm>
           <a:prstGeom prst="roundRect">
             <a:avLst>
@@ -4856,7 +4886,7 @@
         <p:spPr>
           <a:xfrm>
             <a:off x="7992000" y="1417320"/>
-            <a:ext cx="3381120" cy="455040"/>
+            <a:ext cx="3380760" cy="454680"/>
           </a:xfrm>
           <a:prstGeom prst="roundRect">
             <a:avLst>
@@ -4899,7 +4929,7 @@
         <p:spPr>
           <a:xfrm>
             <a:off x="7992000" y="1481400"/>
-            <a:ext cx="3381120" cy="212760"/>
+            <a:ext cx="3380760" cy="212760"/>
           </a:xfrm>
           <a:prstGeom prst="rect">
             <a:avLst/>
@@ -4951,7 +4981,7 @@
         <p:spPr>
           <a:xfrm>
             <a:off x="8174880" y="2011680"/>
-            <a:ext cx="3015360" cy="197640"/>
+            <a:ext cx="3015000" cy="197640"/>
           </a:xfrm>
           <a:prstGeom prst="rect">
             <a:avLst/>
@@ -5003,7 +5033,7 @@
         <p:spPr>
           <a:xfrm>
             <a:off x="768240" y="3017520"/>
-            <a:ext cx="10604880" cy="212760"/>
+            <a:ext cx="10604520" cy="212760"/>
           </a:xfrm>
           <a:prstGeom prst="rect">
             <a:avLst/>
@@ -5055,7 +5085,7 @@
         <p:spPr>
           <a:xfrm>
             <a:off x="768240" y="3474720"/>
-            <a:ext cx="1204920" cy="637920"/>
+            <a:ext cx="1204560" cy="637560"/>
           </a:xfrm>
           <a:prstGeom prst="roundRect">
             <a:avLst>
@@ -5098,7 +5128,7 @@
         <p:spPr>
           <a:xfrm>
             <a:off x="804600" y="3721680"/>
-            <a:ext cx="1131840" cy="144000"/>
+            <a:ext cx="1131480" cy="144000"/>
           </a:xfrm>
           <a:prstGeom prst="rect">
             <a:avLst/>
@@ -5150,7 +5180,7 @@
         <p:spPr>
           <a:xfrm>
             <a:off x="1956960" y="3672360"/>
-            <a:ext cx="162360" cy="242640"/>
+            <a:ext cx="162000" cy="242640"/>
           </a:xfrm>
           <a:prstGeom prst="rect">
             <a:avLst/>
@@ -5202,7 +5232,7 @@
         <p:spPr>
           <a:xfrm>
             <a:off x="2103120" y="3474720"/>
-            <a:ext cx="1204920" cy="637920"/>
+            <a:ext cx="1204560" cy="637560"/>
           </a:xfrm>
           <a:prstGeom prst="roundRect">
             <a:avLst>
@@ -5245,7 +5275,7 @@
         <p:spPr>
           <a:xfrm>
             <a:off x="2139840" y="3721680"/>
-            <a:ext cx="1131840" cy="144000"/>
+            <a:ext cx="1131480" cy="144000"/>
           </a:xfrm>
           <a:prstGeom prst="rect">
             <a:avLst/>
@@ -5297,7 +5327,7 @@
         <p:spPr>
           <a:xfrm>
             <a:off x="3291840" y="3672360"/>
-            <a:ext cx="162360" cy="242640"/>
+            <a:ext cx="162000" cy="242640"/>
           </a:xfrm>
           <a:prstGeom prst="rect">
             <a:avLst/>
@@ -5349,7 +5379,7 @@
         <p:spPr>
           <a:xfrm>
             <a:off x="3438000" y="3474720"/>
-            <a:ext cx="1204920" cy="637920"/>
+            <a:ext cx="1204560" cy="637560"/>
           </a:xfrm>
           <a:prstGeom prst="roundRect">
             <a:avLst>
@@ -5392,7 +5422,7 @@
         <p:spPr>
           <a:xfrm>
             <a:off x="3474720" y="3721680"/>
-            <a:ext cx="1131840" cy="144000"/>
+            <a:ext cx="1131480" cy="144000"/>
           </a:xfrm>
           <a:prstGeom prst="rect">
             <a:avLst/>
@@ -5444,7 +5474,7 @@
         <p:spPr>
           <a:xfrm>
             <a:off x="4626720" y="3672360"/>
-            <a:ext cx="162360" cy="242640"/>
+            <a:ext cx="162000" cy="242640"/>
           </a:xfrm>
           <a:prstGeom prst="rect">
             <a:avLst/>
@@ -5496,7 +5526,7 @@
         <p:spPr>
           <a:xfrm>
             <a:off x="4773240" y="3474720"/>
-            <a:ext cx="1204920" cy="637920"/>
+            <a:ext cx="1204560" cy="637560"/>
           </a:xfrm>
           <a:prstGeom prst="roundRect">
             <a:avLst>
@@ -5539,7 +5569,7 @@
         <p:spPr>
           <a:xfrm>
             <a:off x="4809600" y="3649320"/>
-            <a:ext cx="1131840" cy="288720"/>
+            <a:ext cx="1131480" cy="288720"/>
           </a:xfrm>
           <a:prstGeom prst="rect">
             <a:avLst/>
@@ -5591,7 +5621,7 @@
         <p:spPr>
           <a:xfrm>
             <a:off x="5961960" y="3672360"/>
-            <a:ext cx="162360" cy="242640"/>
+            <a:ext cx="162000" cy="242640"/>
           </a:xfrm>
           <a:prstGeom prst="rect">
             <a:avLst/>
@@ -5643,7 +5673,7 @@
         <p:spPr>
           <a:xfrm>
             <a:off x="6108120" y="3474720"/>
-            <a:ext cx="1204920" cy="637920"/>
+            <a:ext cx="1204560" cy="637560"/>
           </a:xfrm>
           <a:prstGeom prst="roundRect">
             <a:avLst>
@@ -5686,7 +5716,7 @@
         <p:spPr>
           <a:xfrm>
             <a:off x="6144840" y="3721680"/>
-            <a:ext cx="1131840" cy="144000"/>
+            <a:ext cx="1131480" cy="144000"/>
           </a:xfrm>
           <a:prstGeom prst="rect">
             <a:avLst/>
@@ -5738,7 +5768,7 @@
         <p:spPr>
           <a:xfrm>
             <a:off x="7296840" y="3672360"/>
-            <a:ext cx="162360" cy="242640"/>
+            <a:ext cx="162000" cy="242640"/>
           </a:xfrm>
           <a:prstGeom prst="rect">
             <a:avLst/>
@@ -5790,7 +5820,7 @@
         <p:spPr>
           <a:xfrm>
             <a:off x="7443360" y="3474720"/>
-            <a:ext cx="1204920" cy="637920"/>
+            <a:ext cx="1204560" cy="637560"/>
           </a:xfrm>
           <a:prstGeom prst="roundRect">
             <a:avLst>
@@ -5833,7 +5863,7 @@
         <p:spPr>
           <a:xfrm>
             <a:off x="7479720" y="3721680"/>
-            <a:ext cx="1131840" cy="144000"/>
+            <a:ext cx="1131480" cy="144000"/>
           </a:xfrm>
           <a:prstGeom prst="rect">
             <a:avLst/>
@@ -5885,7 +5915,7 @@
         <p:spPr>
           <a:xfrm>
             <a:off x="8632080" y="3672360"/>
-            <a:ext cx="162360" cy="242640"/>
+            <a:ext cx="162000" cy="242640"/>
           </a:xfrm>
           <a:prstGeom prst="rect">
             <a:avLst/>
@@ -5937,7 +5967,7 @@
         <p:spPr>
           <a:xfrm>
             <a:off x="8778240" y="3474720"/>
-            <a:ext cx="1204920" cy="637920"/>
+            <a:ext cx="1204560" cy="637560"/>
           </a:xfrm>
           <a:prstGeom prst="roundRect">
             <a:avLst>
@@ -5980,7 +6010,7 @@
         <p:spPr>
           <a:xfrm>
             <a:off x="8814960" y="3721680"/>
-            <a:ext cx="1131840" cy="144000"/>
+            <a:ext cx="1131480" cy="144000"/>
           </a:xfrm>
           <a:prstGeom prst="rect">
             <a:avLst/>
@@ -6032,7 +6062,7 @@
         <p:spPr>
           <a:xfrm>
             <a:off x="9966960" y="3672360"/>
-            <a:ext cx="162360" cy="242640"/>
+            <a:ext cx="162000" cy="242640"/>
           </a:xfrm>
           <a:prstGeom prst="rect">
             <a:avLst/>
@@ -6084,7 +6114,7 @@
         <p:spPr>
           <a:xfrm>
             <a:off x="10113120" y="3474720"/>
-            <a:ext cx="1204920" cy="637920"/>
+            <a:ext cx="1204560" cy="637560"/>
           </a:xfrm>
           <a:prstGeom prst="roundRect">
             <a:avLst>
@@ -6127,7 +6157,7 @@
         <p:spPr>
           <a:xfrm>
             <a:off x="10149840" y="3721680"/>
-            <a:ext cx="1131840" cy="144000"/>
+            <a:ext cx="1131480" cy="144000"/>
           </a:xfrm>
           <a:prstGeom prst="rect">
             <a:avLst/>
@@ -6179,7 +6209,7 @@
         <p:spPr>
           <a:xfrm>
             <a:off x="768240" y="4389120"/>
-            <a:ext cx="10650600" cy="683640"/>
+            <a:ext cx="10650240" cy="683280"/>
           </a:xfrm>
           <a:prstGeom prst="roundRect">
             <a:avLst>
@@ -6222,7 +6252,7 @@
         <p:spPr>
           <a:xfrm>
             <a:off x="768240" y="4389120"/>
-            <a:ext cx="48600" cy="683640"/>
+            <a:ext cx="48240" cy="683280"/>
           </a:xfrm>
           <a:prstGeom prst="rect">
             <a:avLst/>
@@ -6263,7 +6293,7 @@
         <p:spPr>
           <a:xfrm>
             <a:off x="1024200" y="4542120"/>
-            <a:ext cx="10193400" cy="414720"/>
+            <a:ext cx="10193040" cy="414720"/>
           </a:xfrm>
           <a:prstGeom prst="rect">
             <a:avLst/>
@@ -6352,7 +6382,7 @@
         <p:spPr>
           <a:xfrm>
             <a:off x="683280" y="495000"/>
-            <a:ext cx="11109960" cy="964080"/>
+            <a:ext cx="11109600" cy="963720"/>
           </a:xfrm>
           <a:prstGeom prst="rect">
             <a:avLst/>
@@ -6378,7 +6408,7 @@
         <p:spPr>
           <a:xfrm>
             <a:off x="4010760" y="2105280"/>
-            <a:ext cx="8179200" cy="3029040"/>
+            <a:ext cx="8178840" cy="3028680"/>
           </a:xfrm>
           <a:prstGeom prst="rect">
             <a:avLst/>
@@ -6546,7 +6576,7 @@
         <p:spPr>
           <a:xfrm>
             <a:off x="223200" y="6287400"/>
-            <a:ext cx="540360" cy="362880"/>
+            <a:ext cx="540000" cy="362520"/>
           </a:xfrm>
           <a:prstGeom prst="rect">
             <a:avLst/>
@@ -6572,7 +6602,7 @@
         <p:spPr>
           <a:xfrm>
             <a:off x="765720" y="6287400"/>
-            <a:ext cx="4617720" cy="362880"/>
+            <a:ext cx="4617360" cy="362520"/>
           </a:xfrm>
           <a:prstGeom prst="rect">
             <a:avLst/>
@@ -6598,7 +6628,7 @@
         <p:spPr>
           <a:xfrm>
             <a:off x="3049200" y="3275280"/>
-            <a:ext cx="6091560" cy="363960"/>
+            <a:ext cx="6091200" cy="363960"/>
           </a:xfrm>
           <a:prstGeom prst="rect">
             <a:avLst/>
@@ -6654,7 +6684,7 @@
         <p:spPr>
           <a:xfrm>
             <a:off x="6506640" y="426240"/>
-            <a:ext cx="2634120" cy="1222560"/>
+            <a:ext cx="2633760" cy="1222200"/>
           </a:xfrm>
           <a:prstGeom prst="rect">
             <a:avLst/>
@@ -6678,7 +6708,7 @@
         <p:spPr>
           <a:xfrm>
             <a:off x="500040" y="495000"/>
-            <a:ext cx="2941200" cy="5837400"/>
+            <a:ext cx="2940840" cy="5837040"/>
           </a:xfrm>
           <a:prstGeom prst="rect">
             <a:avLst/>
@@ -6697,7 +6727,7 @@
         <p:spPr>
           <a:xfrm>
             <a:off x="0" y="6437520"/>
-            <a:ext cx="12189600" cy="12960"/>
+            <a:ext cx="12189240" cy="12600"/>
           </a:xfrm>
           <a:prstGeom prst="rect">
             <a:avLst/>
@@ -6879,7 +6909,7 @@
         <p:spPr>
           <a:xfrm>
             <a:off x="825480" y="419760"/>
-            <a:ext cx="5634720" cy="928440"/>
+            <a:ext cx="5634360" cy="928080"/>
           </a:xfrm>
           <a:prstGeom prst="rect">
             <a:avLst/>
@@ -6931,7 +6961,7 @@
         <p:spPr>
           <a:xfrm>
             <a:off x="825480" y="1455840"/>
-            <a:ext cx="5634720" cy="880560"/>
+            <a:ext cx="5634360" cy="880200"/>
           </a:xfrm>
           <a:prstGeom prst="rect">
             <a:avLst/>
@@ -7003,7 +7033,7 @@
         <p:spPr>
           <a:xfrm>
             <a:off x="825480" y="2445480"/>
-            <a:ext cx="5470560" cy="1692360"/>
+            <a:ext cx="5470200" cy="1692000"/>
           </a:xfrm>
           <a:prstGeom prst="roundRect">
             <a:avLst>
@@ -7043,7 +7073,7 @@
         <p:spPr>
           <a:xfrm>
             <a:off x="1074600" y="2777040"/>
-            <a:ext cx="5121360" cy="754560"/>
+            <a:ext cx="5121000" cy="754200"/>
           </a:xfrm>
           <a:prstGeom prst="rect">
             <a:avLst/>
@@ -7095,7 +7125,7 @@
         <p:spPr>
           <a:xfrm>
             <a:off x="1074600" y="3597480"/>
-            <a:ext cx="5121360" cy="450000"/>
+            <a:ext cx="5121000" cy="449640"/>
           </a:xfrm>
           <a:prstGeom prst="rect">
             <a:avLst/>
@@ -7147,7 +7177,7 @@
         <p:spPr>
           <a:xfrm>
             <a:off x="825480" y="4417920"/>
-            <a:ext cx="5470560" cy="1838520"/>
+            <a:ext cx="5470200" cy="1838160"/>
           </a:xfrm>
           <a:prstGeom prst="roundRect">
             <a:avLst>
@@ -7191,7 +7221,7 @@
         <p:spPr>
           <a:xfrm>
             <a:off x="1074600" y="4592880"/>
-            <a:ext cx="4972320" cy="258120"/>
+            <a:ext cx="4971960" cy="257760"/>
           </a:xfrm>
           <a:prstGeom prst="roundRect">
             <a:avLst>
@@ -7221,7 +7251,7 @@
         <p:spPr>
           <a:xfrm>
             <a:off x="1176120" y="4607640"/>
-            <a:ext cx="4918320" cy="243360"/>
+            <a:ext cx="4917960" cy="243000"/>
           </a:xfrm>
           <a:prstGeom prst="rect">
             <a:avLst/>
@@ -7273,7 +7303,7 @@
         <p:spPr>
           <a:xfrm>
             <a:off x="1074600" y="4846680"/>
-            <a:ext cx="5121360" cy="1192680"/>
+            <a:ext cx="5121000" cy="1192320"/>
           </a:xfrm>
           <a:prstGeom prst="rect">
             <a:avLst/>
@@ -7485,7 +7515,7 @@
         <p:spPr>
           <a:xfrm>
             <a:off x="6896160" y="784080"/>
-            <a:ext cx="4276080" cy="4830480"/>
+            <a:ext cx="4275720" cy="4830120"/>
           </a:xfrm>
           <a:prstGeom prst="roundRect">
             <a:avLst>
@@ -7529,7 +7559,7 @@
         <p:spPr>
           <a:xfrm>
             <a:off x="6904440" y="792000"/>
-            <a:ext cx="4260240" cy="4814640"/>
+            <a:ext cx="4259880" cy="4814280"/>
           </a:xfrm>
           <a:prstGeom prst="rect">
             <a:avLst/>
@@ -7548,7 +7578,7 @@
         <p:spPr>
           <a:xfrm>
             <a:off x="6634800" y="5730840"/>
-            <a:ext cx="4799520" cy="251640"/>
+            <a:ext cx="4799160" cy="251280"/>
           </a:xfrm>
           <a:prstGeom prst="rect">
             <a:avLst/>
@@ -7600,7 +7630,7 @@
         <p:spPr>
           <a:xfrm>
             <a:off x="0" y="6437520"/>
-            <a:ext cx="12189600" cy="12960"/>
+            <a:ext cx="12189240" cy="12600"/>
           </a:xfrm>
           <a:prstGeom prst="rect">
             <a:avLst/>
@@ -7745,7 +7775,7 @@
         <p:spPr>
           <a:xfrm>
             <a:off x="825480" y="1360080"/>
-            <a:ext cx="1369440" cy="42120"/>
+            <a:ext cx="1369080" cy="41760"/>
           </a:xfrm>
           <a:prstGeom prst="rect">
             <a:avLst/>
@@ -7823,7 +7853,7 @@
         <p:spPr>
           <a:xfrm>
             <a:off x="1020240" y="571680"/>
-            <a:ext cx="4068000" cy="5027400"/>
+            <a:ext cx="4067640" cy="5027040"/>
           </a:xfrm>
           <a:prstGeom prst="roundRect">
             <a:avLst>
@@ -7869,7 +7899,7 @@
         <p:spPr>
           <a:xfrm>
             <a:off x="1028160" y="579600"/>
-            <a:ext cx="4052160" cy="5011560"/>
+            <a:ext cx="4051800" cy="5011200"/>
           </a:xfrm>
           <a:prstGeom prst="rect">
             <a:avLst/>
@@ -7888,7 +7918,7 @@
         <p:spPr>
           <a:xfrm>
             <a:off x="758520" y="5715360"/>
-            <a:ext cx="4590720" cy="480240"/>
+            <a:ext cx="4590360" cy="479880"/>
           </a:xfrm>
           <a:prstGeom prst="rect">
             <a:avLst/>
@@ -7940,7 +7970,7 @@
         <p:spPr>
           <a:xfrm>
             <a:off x="5691240" y="1323360"/>
-            <a:ext cx="5843520" cy="928440"/>
+            <a:ext cx="5843160" cy="928080"/>
           </a:xfrm>
           <a:prstGeom prst="rect">
             <a:avLst/>
@@ -7992,7 +8022,7 @@
         <p:spPr>
           <a:xfrm>
             <a:off x="5691240" y="2418840"/>
-            <a:ext cx="5843520" cy="880560"/>
+            <a:ext cx="5843160" cy="880200"/>
           </a:xfrm>
           <a:prstGeom prst="rect">
             <a:avLst/>
@@ -8084,7 +8114,7 @@
         <p:spPr>
           <a:xfrm>
             <a:off x="5691240" y="3467880"/>
-            <a:ext cx="2746800" cy="1683000"/>
+            <a:ext cx="2746440" cy="1682640"/>
           </a:xfrm>
           <a:prstGeom prst="roundRect">
             <a:avLst>
@@ -8124,7 +8154,7 @@
         <p:spPr>
           <a:xfrm>
             <a:off x="5927400" y="3687120"/>
-            <a:ext cx="2341800" cy="754560"/>
+            <a:ext cx="2341440" cy="754200"/>
           </a:xfrm>
           <a:prstGeom prst="rect">
             <a:avLst/>
@@ -8176,7 +8206,7 @@
         <p:spPr>
           <a:xfrm>
             <a:off x="5791680" y="4507200"/>
-            <a:ext cx="2646000" cy="450000"/>
+            <a:ext cx="2645640" cy="449640"/>
           </a:xfrm>
           <a:prstGeom prst="rect">
             <a:avLst/>
@@ -8228,7 +8258,7 @@
         <p:spPr>
           <a:xfrm>
             <a:off x="8617680" y="3467880"/>
-            <a:ext cx="2746800" cy="1683000"/>
+            <a:ext cx="2746440" cy="1682640"/>
           </a:xfrm>
           <a:prstGeom prst="roundRect">
             <a:avLst>
@@ -8268,7 +8298,7 @@
         <p:spPr>
           <a:xfrm>
             <a:off x="8854200" y="3678840"/>
-            <a:ext cx="2341800" cy="754560"/>
+            <a:ext cx="2341440" cy="754200"/>
           </a:xfrm>
           <a:prstGeom prst="rect">
             <a:avLst/>
@@ -8320,7 +8350,7 @@
         <p:spPr>
           <a:xfrm>
             <a:off x="8854200" y="4499280"/>
-            <a:ext cx="2341800" cy="465840"/>
+            <a:ext cx="2341440" cy="465480"/>
           </a:xfrm>
           <a:prstGeom prst="rect">
             <a:avLst/>
@@ -8412,7 +8442,7 @@
         <p:spPr>
           <a:xfrm>
             <a:off x="5691240" y="5346720"/>
-            <a:ext cx="5843520" cy="534960"/>
+            <a:ext cx="5843160" cy="534600"/>
           </a:xfrm>
           <a:prstGeom prst="rect">
             <a:avLst/>
@@ -8484,7 +8514,7 @@
         <p:spPr>
           <a:xfrm>
             <a:off x="0" y="6437520"/>
-            <a:ext cx="12189600" cy="12960"/>
+            <a:ext cx="12189240" cy="12600"/>
           </a:xfrm>
           <a:prstGeom prst="rect">
             <a:avLst/>
@@ -8629,7 +8659,7 @@
         <p:spPr>
           <a:xfrm>
             <a:off x="5691240" y="2299320"/>
-            <a:ext cx="1369440" cy="42120"/>
+            <a:ext cx="1369080" cy="41760"/>
           </a:xfrm>
           <a:prstGeom prst="rect">
             <a:avLst/>
@@ -8707,7 +8737,7 @@
         <p:spPr>
           <a:xfrm>
             <a:off x="825480" y="852480"/>
-            <a:ext cx="10855080" cy="475920"/>
+            <a:ext cx="10854720" cy="475560"/>
           </a:xfrm>
           <a:prstGeom prst="rect">
             <a:avLst/>
@@ -8769,7 +8799,7 @@
         <p:spPr>
           <a:xfrm>
             <a:off x="825480" y="1548360"/>
-            <a:ext cx="9154440" cy="594720"/>
+            <a:ext cx="9154080" cy="594360"/>
           </a:xfrm>
           <a:prstGeom prst="rect">
             <a:avLst/>
@@ -8821,7 +8851,7 @@
         <p:spPr>
           <a:xfrm>
             <a:off x="825480" y="2435040"/>
-            <a:ext cx="4717080" cy="3887640"/>
+            <a:ext cx="4716720" cy="3887280"/>
           </a:xfrm>
           <a:prstGeom prst="roundRect">
             <a:avLst>
@@ -8861,7 +8891,7 @@
         <p:spPr>
           <a:xfrm>
             <a:off x="1138320" y="3220920"/>
-            <a:ext cx="4091760" cy="258120"/>
+            <a:ext cx="4091400" cy="257760"/>
           </a:xfrm>
           <a:prstGeom prst="roundRect">
             <a:avLst>
@@ -8891,7 +8921,7 @@
         <p:spPr>
           <a:xfrm>
             <a:off x="1239840" y="3271680"/>
-            <a:ext cx="4011120" cy="181800"/>
+            <a:ext cx="4010760" cy="181440"/>
           </a:xfrm>
           <a:prstGeom prst="rect">
             <a:avLst/>
@@ -8943,7 +8973,7 @@
         <p:spPr>
           <a:xfrm>
             <a:off x="1138320" y="3620880"/>
-            <a:ext cx="211320" cy="286200"/>
+            <a:ext cx="210960" cy="285840"/>
           </a:xfrm>
           <a:prstGeom prst="rect">
             <a:avLst/>
@@ -8961,7 +8991,7 @@
         </p:style>
         <p:txBody>
           <a:bodyPr lIns="16920" rIns="16920" tIns="16920" bIns="16920" anchor="t">
-            <a:normAutofit fontScale="80000"/>
+            <a:normAutofit fontScale="79000"/>
           </a:bodyPr>
           <a:p>
             <a:pPr>
@@ -8995,7 +9025,7 @@
         <p:spPr>
           <a:xfrm>
             <a:off x="1415160" y="3624120"/>
-            <a:ext cx="1160640" cy="279000"/>
+            <a:ext cx="1160280" cy="278640"/>
           </a:xfrm>
           <a:prstGeom prst="rect">
             <a:avLst/>
@@ -9047,7 +9077,7 @@
         <p:spPr>
           <a:xfrm>
             <a:off x="1886040" y="3972240"/>
-            <a:ext cx="390600" cy="252000"/>
+            <a:ext cx="390240" cy="251640"/>
           </a:xfrm>
           <a:prstGeom prst="rect">
             <a:avLst/>
@@ -9065,7 +9095,7 @@
         </p:style>
         <p:txBody>
           <a:bodyPr lIns="16920" rIns="16920" tIns="16920" bIns="16920" anchor="t">
-            <a:normAutofit fontScale="80000"/>
+            <a:normAutofit fontScale="79000"/>
           </a:bodyPr>
           <a:p>
             <a:pPr>
@@ -9099,7 +9129,7 @@
         <p:spPr>
           <a:xfrm>
             <a:off x="1138320" y="4289760"/>
-            <a:ext cx="211320" cy="286200"/>
+            <a:ext cx="210960" cy="285840"/>
           </a:xfrm>
           <a:prstGeom prst="rect">
             <a:avLst/>
@@ -9117,7 +9147,7 @@
         </p:style>
         <p:txBody>
           <a:bodyPr lIns="16920" rIns="16920" tIns="16920" bIns="16920" anchor="t">
-            <a:normAutofit fontScale="80000"/>
+            <a:normAutofit fontScale="79000"/>
           </a:bodyPr>
           <a:p>
             <a:pPr>
@@ -9151,7 +9181,7 @@
         <p:spPr>
           <a:xfrm>
             <a:off x="1415160" y="4293360"/>
-            <a:ext cx="1599840" cy="279000"/>
+            <a:ext cx="1599480" cy="278640"/>
           </a:xfrm>
           <a:prstGeom prst="rect">
             <a:avLst/>
@@ -9203,7 +9233,7 @@
         <p:spPr>
           <a:xfrm>
             <a:off x="1886040" y="4641480"/>
-            <a:ext cx="390600" cy="252000"/>
+            <a:ext cx="390240" cy="251640"/>
           </a:xfrm>
           <a:prstGeom prst="rect">
             <a:avLst/>
@@ -9221,7 +9251,7 @@
         </p:style>
         <p:txBody>
           <a:bodyPr lIns="16920" rIns="16920" tIns="16920" bIns="16920" anchor="t">
-            <a:normAutofit fontScale="80000"/>
+            <a:normAutofit fontScale="79000"/>
           </a:bodyPr>
           <a:p>
             <a:pPr>
@@ -9255,7 +9285,7 @@
         <p:spPr>
           <a:xfrm>
             <a:off x="1138320" y="4958640"/>
-            <a:ext cx="211320" cy="286200"/>
+            <a:ext cx="210960" cy="285840"/>
           </a:xfrm>
           <a:prstGeom prst="rect">
             <a:avLst/>
@@ -9273,7 +9303,7 @@
         </p:style>
         <p:txBody>
           <a:bodyPr lIns="16920" rIns="16920" tIns="16920" bIns="16920" anchor="t">
-            <a:normAutofit fontScale="80000"/>
+            <a:normAutofit fontScale="79000"/>
           </a:bodyPr>
           <a:p>
             <a:pPr>
@@ -9307,7 +9337,7 @@
         <p:spPr>
           <a:xfrm>
             <a:off x="1415160" y="4962240"/>
-            <a:ext cx="1333080" cy="279000"/>
+            <a:ext cx="1332720" cy="278640"/>
           </a:xfrm>
           <a:prstGeom prst="rect">
             <a:avLst/>
@@ -9359,7 +9389,7 @@
         <p:spPr>
           <a:xfrm>
             <a:off x="1290600" y="5310360"/>
-            <a:ext cx="4061880" cy="251640"/>
+            <a:ext cx="4061520" cy="251280"/>
           </a:xfrm>
           <a:prstGeom prst="rect">
             <a:avLst/>
@@ -9421,7 +9451,7 @@
         <p:spPr>
           <a:xfrm>
             <a:off x="5849280" y="2435040"/>
-            <a:ext cx="2680200" cy="1655280"/>
+            <a:ext cx="2679840" cy="1654920"/>
           </a:xfrm>
           <a:prstGeom prst="roundRect">
             <a:avLst>
@@ -9461,7 +9491,7 @@
         <p:spPr>
           <a:xfrm>
             <a:off x="6073200" y="2777400"/>
-            <a:ext cx="2299680" cy="480240"/>
+            <a:ext cx="2299320" cy="479880"/>
           </a:xfrm>
           <a:prstGeom prst="rect">
             <a:avLst/>
@@ -9513,7 +9543,7 @@
         <p:spPr>
           <a:xfrm>
             <a:off x="6073200" y="3323520"/>
-            <a:ext cx="2299680" cy="450000"/>
+            <a:ext cx="2299320" cy="449640"/>
           </a:xfrm>
           <a:prstGeom prst="rect">
             <a:avLst/>
@@ -9565,7 +9595,7 @@
         <p:spPr>
           <a:xfrm>
             <a:off x="8683920" y="2435040"/>
-            <a:ext cx="2680200" cy="1655280"/>
+            <a:ext cx="2679840" cy="1654920"/>
           </a:xfrm>
           <a:prstGeom prst="roundRect">
             <a:avLst>
@@ -9605,7 +9635,7 @@
         <p:spPr>
           <a:xfrm>
             <a:off x="8907840" y="2777400"/>
-            <a:ext cx="2300040" cy="480240"/>
+            <a:ext cx="2299680" cy="479880"/>
           </a:xfrm>
           <a:prstGeom prst="rect">
             <a:avLst/>
@@ -9657,7 +9687,7 @@
         <p:spPr>
           <a:xfrm>
             <a:off x="8907840" y="3323520"/>
-            <a:ext cx="2300040" cy="450000"/>
+            <a:ext cx="2299680" cy="449640"/>
           </a:xfrm>
           <a:prstGeom prst="rect">
             <a:avLst/>
@@ -9709,7 +9739,7 @@
         <p:spPr>
           <a:xfrm>
             <a:off x="5849280" y="4245120"/>
-            <a:ext cx="5515200" cy="2077560"/>
+            <a:ext cx="5514840" cy="2077200"/>
           </a:xfrm>
           <a:prstGeom prst="roundRect">
             <a:avLst>
@@ -9749,7 +9779,7 @@
         <p:spPr>
           <a:xfrm>
             <a:off x="6085800" y="4581360"/>
-            <a:ext cx="1509120" cy="480240"/>
+            <a:ext cx="1508760" cy="479880"/>
           </a:xfrm>
           <a:prstGeom prst="rect">
             <a:avLst/>
@@ -9801,7 +9831,7 @@
         <p:spPr>
           <a:xfrm>
             <a:off x="7673400" y="4755960"/>
-            <a:ext cx="668520" cy="274680"/>
+            <a:ext cx="668160" cy="274320"/>
           </a:xfrm>
           <a:prstGeom prst="rect">
             <a:avLst/>
@@ -9853,7 +9883,7 @@
         <p:spPr>
           <a:xfrm>
             <a:off x="6085800" y="5127120"/>
-            <a:ext cx="5193360" cy="884520"/>
+            <a:ext cx="5193000" cy="884160"/>
           </a:xfrm>
           <a:prstGeom prst="rect">
             <a:avLst/>
@@ -9945,7 +9975,7 @@
         <p:spPr>
           <a:xfrm>
             <a:off x="0" y="6437520"/>
-            <a:ext cx="12189600" cy="12960"/>
+            <a:ext cx="12189240" cy="12600"/>
           </a:xfrm>
           <a:prstGeom prst="rect">
             <a:avLst/>
@@ -10090,7 +10120,7 @@
         <p:spPr>
           <a:xfrm>
             <a:off x="825480" y="1375920"/>
-            <a:ext cx="1369440" cy="42120"/>
+            <a:ext cx="1369080" cy="41760"/>
           </a:xfrm>
           <a:prstGeom prst="rect">
             <a:avLst/>
@@ -10168,7 +10198,7 @@
         <p:spPr>
           <a:xfrm>
             <a:off x="768240" y="1554480"/>
-            <a:ext cx="1826640" cy="48600"/>
+            <a:ext cx="1826280" cy="48240"/>
           </a:xfrm>
           <a:prstGeom prst="rect">
             <a:avLst/>
@@ -10209,7 +10239,7 @@
         <p:spPr>
           <a:xfrm>
             <a:off x="768240" y="1737360"/>
-            <a:ext cx="10422000" cy="578880"/>
+            <a:ext cx="10421640" cy="578880"/>
           </a:xfrm>
           <a:prstGeom prst="rect">
             <a:avLst/>
@@ -10261,7 +10291,7 @@
         <p:spPr>
           <a:xfrm>
             <a:off x="768240" y="2697480"/>
-            <a:ext cx="10056240" cy="273960"/>
+            <a:ext cx="10055880" cy="273960"/>
           </a:xfrm>
           <a:prstGeom prst="rect">
             <a:avLst/>
@@ -10313,7 +10343,7 @@
         <p:spPr>
           <a:xfrm>
             <a:off x="768240" y="3566160"/>
-            <a:ext cx="6398640" cy="1003680"/>
+            <a:ext cx="6398280" cy="1003320"/>
           </a:xfrm>
           <a:prstGeom prst="roundRect">
             <a:avLst>
@@ -10356,7 +10386,7 @@
         <p:spPr>
           <a:xfrm>
             <a:off x="768240" y="3703320"/>
-            <a:ext cx="6398640" cy="197640"/>
+            <a:ext cx="6398280" cy="197640"/>
           </a:xfrm>
           <a:prstGeom prst="rect">
             <a:avLst/>
@@ -10408,7 +10438,7 @@
         <p:spPr>
           <a:xfrm>
             <a:off x="768240" y="4041720"/>
-            <a:ext cx="6398640" cy="365400"/>
+            <a:ext cx="6398280" cy="365400"/>
           </a:xfrm>
           <a:prstGeom prst="rect">
             <a:avLst/>
@@ -10460,7 +10490,7 @@
         <p:spPr>
           <a:xfrm>
             <a:off x="768240" y="5120640"/>
-            <a:ext cx="2558160" cy="227880"/>
+            <a:ext cx="2557800" cy="227880"/>
           </a:xfrm>
           <a:prstGeom prst="rect">
             <a:avLst/>
@@ -10512,7 +10542,7 @@
         <p:spPr>
           <a:xfrm>
             <a:off x="768240" y="5486400"/>
-            <a:ext cx="2558160" cy="197640"/>
+            <a:ext cx="2557800" cy="197640"/>
           </a:xfrm>
           <a:prstGeom prst="rect">
             <a:avLst/>
@@ -10564,7 +10594,7 @@
         <p:spPr>
           <a:xfrm>
             <a:off x="3465720" y="5120640"/>
-            <a:ext cx="2558160" cy="227880"/>
+            <a:ext cx="2557800" cy="227880"/>
           </a:xfrm>
           <a:prstGeom prst="rect">
             <a:avLst/>
@@ -10616,7 +10646,7 @@
         <p:spPr>
           <a:xfrm>
             <a:off x="3465720" y="5486400"/>
-            <a:ext cx="2558160" cy="395640"/>
+            <a:ext cx="2557800" cy="395640"/>
           </a:xfrm>
           <a:prstGeom prst="rect">
             <a:avLst/>
@@ -10668,7 +10698,7 @@
         <p:spPr>
           <a:xfrm>
             <a:off x="6163200" y="5120640"/>
-            <a:ext cx="2558160" cy="227880"/>
+            <a:ext cx="2557800" cy="227880"/>
           </a:xfrm>
           <a:prstGeom prst="rect">
             <a:avLst/>
@@ -10720,7 +10750,7 @@
         <p:spPr>
           <a:xfrm>
             <a:off x="6163200" y="5486400"/>
-            <a:ext cx="2558160" cy="197640"/>
+            <a:ext cx="2557800" cy="197640"/>
           </a:xfrm>
           <a:prstGeom prst="rect">
             <a:avLst/>
@@ -10772,7 +10802,7 @@
         <p:spPr>
           <a:xfrm>
             <a:off x="8860680" y="5120640"/>
-            <a:ext cx="2558160" cy="227880"/>
+            <a:ext cx="2557800" cy="227880"/>
           </a:xfrm>
           <a:prstGeom prst="rect">
             <a:avLst/>
@@ -10824,7 +10854,7 @@
         <p:spPr>
           <a:xfrm>
             <a:off x="8860680" y="5486400"/>
-            <a:ext cx="2558160" cy="197640"/>
+            <a:ext cx="2557800" cy="197640"/>
           </a:xfrm>
           <a:prstGeom prst="rect">
             <a:avLst/>
@@ -10913,7 +10943,7 @@
         <p:spPr>
           <a:xfrm>
             <a:off x="768240" y="2240280"/>
-            <a:ext cx="1826640" cy="974880"/>
+            <a:ext cx="1826280" cy="974880"/>
           </a:xfrm>
           <a:prstGeom prst="rect">
             <a:avLst/>
@@ -10965,7 +10995,7 @@
         <p:spPr>
           <a:xfrm>
             <a:off x="768240" y="3246120"/>
-            <a:ext cx="1826640" cy="48600"/>
+            <a:ext cx="1826280" cy="48240"/>
           </a:xfrm>
           <a:prstGeom prst="rect">
             <a:avLst/>
@@ -11006,7 +11036,7 @@
         <p:spPr>
           <a:xfrm>
             <a:off x="768240" y="3429000"/>
-            <a:ext cx="10422000" cy="639360"/>
+            <a:ext cx="10421640" cy="639360"/>
           </a:xfrm>
           <a:prstGeom prst="rect">
             <a:avLst/>
@@ -11058,7 +11088,7 @@
         <p:spPr>
           <a:xfrm>
             <a:off x="768240" y="4754880"/>
-            <a:ext cx="7313040" cy="243000"/>
+            <a:ext cx="7312680" cy="243000"/>
           </a:xfrm>
           <a:prstGeom prst="rect">
             <a:avLst/>
@@ -11147,7 +11177,7 @@
         <p:spPr>
           <a:xfrm>
             <a:off x="768240" y="420480"/>
-            <a:ext cx="10604880" cy="441360"/>
+            <a:ext cx="10604520" cy="441360"/>
           </a:xfrm>
           <a:prstGeom prst="rect">
             <a:avLst/>
@@ -11199,7 +11229,7 @@
         <p:spPr>
           <a:xfrm>
             <a:off x="768240" y="1170360"/>
-            <a:ext cx="1369440" cy="42120"/>
+            <a:ext cx="1369080" cy="41760"/>
           </a:xfrm>
           <a:prstGeom prst="rect">
             <a:avLst/>
@@ -11240,7 +11270,7 @@
         <p:spPr>
           <a:xfrm>
             <a:off x="0" y="6437520"/>
-            <a:ext cx="12189600" cy="12960"/>
+            <a:ext cx="12189240" cy="12600"/>
           </a:xfrm>
           <a:prstGeom prst="rect">
             <a:avLst/>
@@ -11281,7 +11311,7 @@
         <p:spPr>
           <a:xfrm>
             <a:off x="768240" y="6473880"/>
-            <a:ext cx="8227440" cy="136800"/>
+            <a:ext cx="8227080" cy="136800"/>
           </a:xfrm>
           <a:prstGeom prst="rect">
             <a:avLst/>
@@ -11333,7 +11363,7 @@
         <p:spPr>
           <a:xfrm>
             <a:off x="10607040" y="6473880"/>
-            <a:ext cx="820800" cy="136800"/>
+            <a:ext cx="820440" cy="136800"/>
           </a:xfrm>
           <a:prstGeom prst="rect">
             <a:avLst/>
@@ -12669,7 +12699,7 @@
         <p:spPr>
           <a:xfrm>
             <a:off x="768240" y="4480560"/>
-            <a:ext cx="10650600" cy="683640"/>
+            <a:ext cx="10650240" cy="683280"/>
           </a:xfrm>
           <a:prstGeom prst="roundRect">
             <a:avLst>
@@ -12712,7 +12742,7 @@
         <p:spPr>
           <a:xfrm>
             <a:off x="768240" y="4480560"/>
-            <a:ext cx="48600" cy="683640"/>
+            <a:ext cx="48240" cy="683280"/>
           </a:xfrm>
           <a:prstGeom prst="rect">
             <a:avLst/>
@@ -12753,7 +12783,7 @@
         <p:spPr>
           <a:xfrm>
             <a:off x="1024200" y="4633560"/>
-            <a:ext cx="10193400" cy="414720"/>
+            <a:ext cx="10193040" cy="414720"/>
           </a:xfrm>
           <a:prstGeom prst="rect">
             <a:avLst/>
@@ -12842,7 +12872,7 @@
         <p:spPr>
           <a:xfrm>
             <a:off x="768240" y="420480"/>
-            <a:ext cx="10604880" cy="441360"/>
+            <a:ext cx="10604520" cy="441360"/>
           </a:xfrm>
           <a:prstGeom prst="rect">
             <a:avLst/>
@@ -12894,7 +12924,7 @@
         <p:spPr>
           <a:xfrm>
             <a:off x="768240" y="1170360"/>
-            <a:ext cx="1369440" cy="42120"/>
+            <a:ext cx="1369080" cy="41760"/>
           </a:xfrm>
           <a:prstGeom prst="rect">
             <a:avLst/>
@@ -12935,7 +12965,7 @@
         <p:spPr>
           <a:xfrm>
             <a:off x="768240" y="1298520"/>
-            <a:ext cx="10604880" cy="227880"/>
+            <a:ext cx="10604520" cy="227880"/>
           </a:xfrm>
           <a:prstGeom prst="rect">
             <a:avLst/>
@@ -12987,7 +13017,7 @@
         <p:spPr>
           <a:xfrm>
             <a:off x="0" y="6437520"/>
-            <a:ext cx="12189600" cy="12960"/>
+            <a:ext cx="12189240" cy="12600"/>
           </a:xfrm>
           <a:prstGeom prst="rect">
             <a:avLst/>
@@ -13028,7 +13058,7 @@
         <p:spPr>
           <a:xfrm>
             <a:off x="768240" y="6473880"/>
-            <a:ext cx="8227440" cy="136800"/>
+            <a:ext cx="8227080" cy="136800"/>
           </a:xfrm>
           <a:prstGeom prst="rect">
             <a:avLst/>
@@ -13080,7 +13110,7 @@
         <p:spPr>
           <a:xfrm>
             <a:off x="10607040" y="6473880"/>
-            <a:ext cx="820800" cy="136800"/>
+            <a:ext cx="820440" cy="136800"/>
           </a:xfrm>
           <a:prstGeom prst="rect">
             <a:avLst/>
@@ -13132,7 +13162,7 @@
         <p:spPr>
           <a:xfrm>
             <a:off x="768240" y="1828800"/>
-            <a:ext cx="10650600" cy="601200"/>
+            <a:ext cx="10650240" cy="600840"/>
           </a:xfrm>
           <a:prstGeom prst="roundRect">
             <a:avLst>
@@ -13175,7 +13205,7 @@
         <p:spPr>
           <a:xfrm>
             <a:off x="768240" y="1828800"/>
-            <a:ext cx="1552320" cy="601200"/>
+            <a:ext cx="1551960" cy="600840"/>
           </a:xfrm>
           <a:prstGeom prst="roundRect">
             <a:avLst>
@@ -13218,7 +13248,7 @@
         <p:spPr>
           <a:xfrm>
             <a:off x="768240" y="1938600"/>
-            <a:ext cx="1552320" cy="227880"/>
+            <a:ext cx="1551960" cy="227880"/>
           </a:xfrm>
           <a:prstGeom prst="rect">
             <a:avLst/>
@@ -13270,7 +13300,7 @@
         <p:spPr>
           <a:xfrm>
             <a:off x="2551320" y="2027160"/>
-            <a:ext cx="8593200" cy="204840"/>
+            <a:ext cx="8592840" cy="204840"/>
           </a:xfrm>
           <a:prstGeom prst="rect">
             <a:avLst/>
@@ -13322,7 +13352,7 @@
         <p:spPr>
           <a:xfrm>
             <a:off x="768240" y="2541960"/>
-            <a:ext cx="10650600" cy="601200"/>
+            <a:ext cx="10650240" cy="600840"/>
           </a:xfrm>
           <a:prstGeom prst="roundRect">
             <a:avLst>
@@ -13365,7 +13395,7 @@
         <p:spPr>
           <a:xfrm>
             <a:off x="768240" y="2541960"/>
-            <a:ext cx="1552320" cy="601200"/>
+            <a:ext cx="1551960" cy="600840"/>
           </a:xfrm>
           <a:prstGeom prst="roundRect">
             <a:avLst>
@@ -13408,7 +13438,7 @@
         <p:spPr>
           <a:xfrm>
             <a:off x="768240" y="2651760"/>
-            <a:ext cx="1552320" cy="227880"/>
+            <a:ext cx="1551960" cy="227880"/>
           </a:xfrm>
           <a:prstGeom prst="rect">
             <a:avLst/>
@@ -13460,7 +13490,7 @@
         <p:spPr>
           <a:xfrm>
             <a:off x="2551320" y="2740320"/>
-            <a:ext cx="8593200" cy="204840"/>
+            <a:ext cx="8592840" cy="204840"/>
           </a:xfrm>
           <a:prstGeom prst="rect">
             <a:avLst/>
@@ -13512,7 +13542,7 @@
         <p:spPr>
           <a:xfrm>
             <a:off x="768240" y="3255120"/>
-            <a:ext cx="10650600" cy="601200"/>
+            <a:ext cx="10650240" cy="600840"/>
           </a:xfrm>
           <a:prstGeom prst="roundRect">
             <a:avLst>
@@ -13555,7 +13585,7 @@
         <p:spPr>
           <a:xfrm>
             <a:off x="768240" y="3255120"/>
-            <a:ext cx="1552320" cy="601200"/>
+            <a:ext cx="1551960" cy="600840"/>
           </a:xfrm>
           <a:prstGeom prst="roundRect">
             <a:avLst>
@@ -13598,7 +13628,7 @@
         <p:spPr>
           <a:xfrm>
             <a:off x="768240" y="3364920"/>
-            <a:ext cx="1552320" cy="227880"/>
+            <a:ext cx="1551960" cy="227880"/>
           </a:xfrm>
           <a:prstGeom prst="rect">
             <a:avLst/>
@@ -13650,7 +13680,7 @@
         <p:spPr>
           <a:xfrm>
             <a:off x="2551320" y="3453480"/>
-            <a:ext cx="8593200" cy="204840"/>
+            <a:ext cx="8592840" cy="204840"/>
           </a:xfrm>
           <a:prstGeom prst="rect">
             <a:avLst/>
@@ -15077,7 +15107,7 @@
         <p:spPr>
           <a:xfrm>
             <a:off x="768240" y="420480"/>
-            <a:ext cx="10604880" cy="441360"/>
+            <a:ext cx="10604520" cy="441360"/>
           </a:xfrm>
           <a:prstGeom prst="rect">
             <a:avLst/>
@@ -15129,7 +15159,7 @@
         <p:spPr>
           <a:xfrm>
             <a:off x="768240" y="1170360"/>
-            <a:ext cx="1369440" cy="42120"/>
+            <a:ext cx="1369080" cy="41760"/>
           </a:xfrm>
           <a:prstGeom prst="rect">
             <a:avLst/>
@@ -15170,7 +15200,7 @@
         <p:spPr>
           <a:xfrm>
             <a:off x="0" y="6437520"/>
-            <a:ext cx="12189600" cy="12960"/>
+            <a:ext cx="12189240" cy="12600"/>
           </a:xfrm>
           <a:prstGeom prst="rect">
             <a:avLst/>
@@ -15211,7 +15241,7 @@
         <p:spPr>
           <a:xfrm>
             <a:off x="768240" y="6473880"/>
-            <a:ext cx="8227440" cy="136800"/>
+            <a:ext cx="8227080" cy="136800"/>
           </a:xfrm>
           <a:prstGeom prst="rect">
             <a:avLst/>
@@ -15263,7 +15293,7 @@
         <p:spPr>
           <a:xfrm>
             <a:off x="10607040" y="6473880"/>
-            <a:ext cx="820800" cy="136800"/>
+            <a:ext cx="820440" cy="136800"/>
           </a:xfrm>
           <a:prstGeom prst="rect">
             <a:avLst/>
@@ -15315,7 +15345,7 @@
         <p:spPr>
           <a:xfrm>
             <a:off x="768240" y="1417320"/>
-            <a:ext cx="10604880" cy="784080"/>
+            <a:ext cx="10604520" cy="783720"/>
           </a:xfrm>
           <a:prstGeom prst="roundRect">
             <a:avLst>
@@ -15358,7 +15388,7 @@
         <p:spPr>
           <a:xfrm>
             <a:off x="951120" y="1581840"/>
-            <a:ext cx="455040" cy="455040"/>
+            <a:ext cx="454680" cy="454680"/>
           </a:xfrm>
           <a:prstGeom prst="ellipse">
             <a:avLst/>
@@ -15399,7 +15429,7 @@
         <p:spPr>
           <a:xfrm>
             <a:off x="951120" y="1668240"/>
-            <a:ext cx="455040" cy="273600"/>
+            <a:ext cx="454680" cy="273600"/>
           </a:xfrm>
           <a:prstGeom prst="rect">
             <a:avLst/>
@@ -15451,7 +15481,7 @@
         <p:spPr>
           <a:xfrm>
             <a:off x="1636920" y="1508760"/>
-            <a:ext cx="6398640" cy="243000"/>
+            <a:ext cx="6398280" cy="243000"/>
           </a:xfrm>
           <a:prstGeom prst="rect">
             <a:avLst/>
@@ -15503,7 +15533,7 @@
         <p:spPr>
           <a:xfrm>
             <a:off x="1636920" y="1837800"/>
-            <a:ext cx="7770240" cy="182160"/>
+            <a:ext cx="7769880" cy="182160"/>
           </a:xfrm>
           <a:prstGeom prst="rect">
             <a:avLst/>
@@ -15555,7 +15585,7 @@
         <p:spPr>
           <a:xfrm>
             <a:off x="9546480" y="1703160"/>
-            <a:ext cx="1735200" cy="212400"/>
+            <a:ext cx="1734840" cy="212400"/>
           </a:xfrm>
           <a:prstGeom prst="rect">
             <a:avLst/>
@@ -15607,7 +15637,7 @@
         <p:spPr>
           <a:xfrm>
             <a:off x="768240" y="2350080"/>
-            <a:ext cx="10604880" cy="784080"/>
+            <a:ext cx="10604520" cy="783720"/>
           </a:xfrm>
           <a:prstGeom prst="roundRect">
             <a:avLst>
@@ -15650,7 +15680,7 @@
         <p:spPr>
           <a:xfrm>
             <a:off x="951120" y="2514600"/>
-            <a:ext cx="455040" cy="455040"/>
+            <a:ext cx="454680" cy="454680"/>
           </a:xfrm>
           <a:prstGeom prst="ellipse">
             <a:avLst/>
@@ -15691,7 +15721,7 @@
         <p:spPr>
           <a:xfrm>
             <a:off x="951120" y="2601000"/>
-            <a:ext cx="455040" cy="273600"/>
+            <a:ext cx="454680" cy="273600"/>
           </a:xfrm>
           <a:prstGeom prst="rect">
             <a:avLst/>
@@ -15743,7 +15773,7 @@
         <p:spPr>
           <a:xfrm>
             <a:off x="1636920" y="2441520"/>
-            <a:ext cx="6398640" cy="243000"/>
+            <a:ext cx="6398280" cy="243000"/>
           </a:xfrm>
           <a:prstGeom prst="rect">
             <a:avLst/>
@@ -15795,7 +15825,7 @@
         <p:spPr>
           <a:xfrm>
             <a:off x="1636920" y="2770560"/>
-            <a:ext cx="7770240" cy="182160"/>
+            <a:ext cx="7769880" cy="182160"/>
           </a:xfrm>
           <a:prstGeom prst="rect">
             <a:avLst/>
@@ -15847,7 +15877,7 @@
         <p:spPr>
           <a:xfrm>
             <a:off x="9546480" y="2635920"/>
-            <a:ext cx="1735200" cy="212400"/>
+            <a:ext cx="1734840" cy="212400"/>
           </a:xfrm>
           <a:prstGeom prst="rect">
             <a:avLst/>
@@ -15899,7 +15929,7 @@
         <p:spPr>
           <a:xfrm>
             <a:off x="768240" y="3282840"/>
-            <a:ext cx="10604880" cy="784080"/>
+            <a:ext cx="10604520" cy="783720"/>
           </a:xfrm>
           <a:prstGeom prst="roundRect">
             <a:avLst>
@@ -15942,7 +15972,7 @@
         <p:spPr>
           <a:xfrm>
             <a:off x="951120" y="3447360"/>
-            <a:ext cx="455040" cy="455040"/>
+            <a:ext cx="454680" cy="454680"/>
           </a:xfrm>
           <a:prstGeom prst="ellipse">
             <a:avLst/>
@@ -15983,7 +16013,7 @@
         <p:spPr>
           <a:xfrm>
             <a:off x="951120" y="3533760"/>
-            <a:ext cx="455040" cy="273600"/>
+            <a:ext cx="454680" cy="273600"/>
           </a:xfrm>
           <a:prstGeom prst="rect">
             <a:avLst/>
@@ -16035,7 +16065,7 @@
         <p:spPr>
           <a:xfrm>
             <a:off x="1636920" y="3374280"/>
-            <a:ext cx="6398640" cy="243000"/>
+            <a:ext cx="6398280" cy="243000"/>
           </a:xfrm>
           <a:prstGeom prst="rect">
             <a:avLst/>
@@ -16087,7 +16117,7 @@
         <p:spPr>
           <a:xfrm>
             <a:off x="1636920" y="3703320"/>
-            <a:ext cx="7770240" cy="182160"/>
+            <a:ext cx="7769880" cy="182160"/>
           </a:xfrm>
           <a:prstGeom prst="rect">
             <a:avLst/>
@@ -16139,7 +16169,7 @@
         <p:spPr>
           <a:xfrm>
             <a:off x="9546480" y="3568680"/>
-            <a:ext cx="1735200" cy="212400"/>
+            <a:ext cx="1734840" cy="212400"/>
           </a:xfrm>
           <a:prstGeom prst="rect">
             <a:avLst/>
@@ -16191,7 +16221,7 @@
         <p:spPr>
           <a:xfrm>
             <a:off x="768240" y="4215240"/>
-            <a:ext cx="10604880" cy="784080"/>
+            <a:ext cx="10604520" cy="783720"/>
           </a:xfrm>
           <a:prstGeom prst="roundRect">
             <a:avLst>
@@ -16234,7 +16264,7 @@
         <p:spPr>
           <a:xfrm>
             <a:off x="951120" y="4380120"/>
-            <a:ext cx="455040" cy="455040"/>
+            <a:ext cx="454680" cy="454680"/>
           </a:xfrm>
           <a:prstGeom prst="ellipse">
             <a:avLst/>
@@ -16275,7 +16305,7 @@
         <p:spPr>
           <a:xfrm>
             <a:off x="951120" y="4466160"/>
-            <a:ext cx="455040" cy="273600"/>
+            <a:ext cx="454680" cy="273600"/>
           </a:xfrm>
           <a:prstGeom prst="rect">
             <a:avLst/>
@@ -16327,7 +16357,7 @@
         <p:spPr>
           <a:xfrm>
             <a:off x="1636920" y="4306680"/>
-            <a:ext cx="6398640" cy="243000"/>
+            <a:ext cx="6398280" cy="243000"/>
           </a:xfrm>
           <a:prstGeom prst="rect">
             <a:avLst/>
@@ -16379,7 +16409,7 @@
         <p:spPr>
           <a:xfrm>
             <a:off x="1636920" y="4636080"/>
-            <a:ext cx="7770240" cy="182160"/>
+            <a:ext cx="7769880" cy="182160"/>
           </a:xfrm>
           <a:prstGeom prst="rect">
             <a:avLst/>
@@ -16431,7 +16461,7 @@
         <p:spPr>
           <a:xfrm>
             <a:off x="9546480" y="4501080"/>
-            <a:ext cx="1735200" cy="212400"/>
+            <a:ext cx="1734840" cy="212400"/>
           </a:xfrm>
           <a:prstGeom prst="rect">
             <a:avLst/>
@@ -16483,7 +16513,7 @@
         <p:spPr>
           <a:xfrm>
             <a:off x="768240" y="5148000"/>
-            <a:ext cx="10604880" cy="784080"/>
+            <a:ext cx="10604520" cy="783720"/>
           </a:xfrm>
           <a:prstGeom prst="roundRect">
             <a:avLst>
@@ -16526,7 +16556,7 @@
         <p:spPr>
           <a:xfrm>
             <a:off x="951120" y="5312520"/>
-            <a:ext cx="455040" cy="455040"/>
+            <a:ext cx="454680" cy="454680"/>
           </a:xfrm>
           <a:prstGeom prst="ellipse">
             <a:avLst/>
@@ -16567,7 +16597,7 @@
         <p:spPr>
           <a:xfrm>
             <a:off x="951120" y="5398920"/>
-            <a:ext cx="455040" cy="273600"/>
+            <a:ext cx="454680" cy="273600"/>
           </a:xfrm>
           <a:prstGeom prst="rect">
             <a:avLst/>
@@ -16619,7 +16649,7 @@
         <p:spPr>
           <a:xfrm>
             <a:off x="1636920" y="5239440"/>
-            <a:ext cx="6398640" cy="243000"/>
+            <a:ext cx="6398280" cy="243000"/>
           </a:xfrm>
           <a:prstGeom prst="rect">
             <a:avLst/>
@@ -16671,7 +16701,7 @@
         <p:spPr>
           <a:xfrm>
             <a:off x="1636920" y="5568840"/>
-            <a:ext cx="7770240" cy="182160"/>
+            <a:ext cx="7769880" cy="182160"/>
           </a:xfrm>
           <a:prstGeom prst="rect">
             <a:avLst/>
@@ -16723,7 +16753,7 @@
         <p:spPr>
           <a:xfrm>
             <a:off x="9546480" y="5433840"/>
-            <a:ext cx="1735200" cy="212400"/>
+            <a:ext cx="1734840" cy="212400"/>
           </a:xfrm>
           <a:prstGeom prst="rect">
             <a:avLst/>
@@ -16812,7 +16842,7 @@
         <p:spPr>
           <a:xfrm>
             <a:off x="768240" y="420480"/>
-            <a:ext cx="10604880" cy="441360"/>
+            <a:ext cx="10604520" cy="441360"/>
           </a:xfrm>
           <a:prstGeom prst="rect">
             <a:avLst/>
@@ -16864,7 +16894,7 @@
         <p:spPr>
           <a:xfrm>
             <a:off x="768240" y="1170360"/>
-            <a:ext cx="1369440" cy="42120"/>
+            <a:ext cx="1369080" cy="41760"/>
           </a:xfrm>
           <a:prstGeom prst="rect">
             <a:avLst/>
@@ -16905,7 +16935,7 @@
         <p:spPr>
           <a:xfrm>
             <a:off x="768240" y="1298520"/>
-            <a:ext cx="10604880" cy="227880"/>
+            <a:ext cx="10604520" cy="227880"/>
           </a:xfrm>
           <a:prstGeom prst="rect">
             <a:avLst/>
@@ -16957,7 +16987,7 @@
         <p:spPr>
           <a:xfrm>
             <a:off x="0" y="6437520"/>
-            <a:ext cx="12189600" cy="12960"/>
+            <a:ext cx="12189240" cy="12600"/>
           </a:xfrm>
           <a:prstGeom prst="rect">
             <a:avLst/>
@@ -16998,7 +17028,7 @@
         <p:spPr>
           <a:xfrm>
             <a:off x="768240" y="6473880"/>
-            <a:ext cx="8227440" cy="136800"/>
+            <a:ext cx="8227080" cy="136800"/>
           </a:xfrm>
           <a:prstGeom prst="rect">
             <a:avLst/>
@@ -17050,7 +17080,7 @@
         <p:spPr>
           <a:xfrm>
             <a:off x="10607040" y="6473880"/>
-            <a:ext cx="820800" cy="136800"/>
+            <a:ext cx="820440" cy="136800"/>
           </a:xfrm>
           <a:prstGeom prst="rect">
             <a:avLst/>
@@ -17102,7 +17132,7 @@
         <p:spPr>
           <a:xfrm>
             <a:off x="768240" y="1828800"/>
-            <a:ext cx="5027040" cy="212760"/>
+            <a:ext cx="5026680" cy="212760"/>
           </a:xfrm>
           <a:prstGeom prst="rect">
             <a:avLst/>
@@ -17154,7 +17184,7 @@
         <p:spPr>
           <a:xfrm>
             <a:off x="768240" y="2194560"/>
-            <a:ext cx="5118480" cy="861840"/>
+            <a:ext cx="5118120" cy="861480"/>
           </a:xfrm>
           <a:prstGeom prst="roundRect">
             <a:avLst>
@@ -17301,7 +17331,7 @@
         <p:spPr>
           <a:xfrm>
             <a:off x="6400800" y="1828800"/>
-            <a:ext cx="5027040" cy="212760"/>
+            <a:ext cx="5026680" cy="212760"/>
           </a:xfrm>
           <a:prstGeom prst="rect">
             <a:avLst/>
@@ -17353,7 +17383,7 @@
         <p:spPr>
           <a:xfrm>
             <a:off x="6400800" y="2194560"/>
-            <a:ext cx="5027040" cy="1328400"/>
+            <a:ext cx="5026680" cy="1328040"/>
           </a:xfrm>
           <a:prstGeom prst="roundRect">
             <a:avLst>
@@ -17572,7 +17602,7 @@
         <p:spPr>
           <a:xfrm>
             <a:off x="768240" y="4206240"/>
-            <a:ext cx="10650600" cy="729360"/>
+            <a:ext cx="10650240" cy="729000"/>
           </a:xfrm>
           <a:prstGeom prst="roundRect">
             <a:avLst>
@@ -17615,7 +17645,7 @@
         <p:spPr>
           <a:xfrm>
             <a:off x="768240" y="4206240"/>
-            <a:ext cx="48600" cy="729360"/>
+            <a:ext cx="48240" cy="729000"/>
           </a:xfrm>
           <a:prstGeom prst="rect">
             <a:avLst/>
@@ -17656,7 +17686,7 @@
         <p:spPr>
           <a:xfrm>
             <a:off x="1024200" y="4271040"/>
-            <a:ext cx="10193400" cy="638280"/>
+            <a:ext cx="10193040" cy="638280"/>
           </a:xfrm>
           <a:prstGeom prst="rect">
             <a:avLst/>
@@ -17776,7 +17806,7 @@
         <p:spPr>
           <a:xfrm>
             <a:off x="768240" y="420480"/>
-            <a:ext cx="10604880" cy="441360"/>
+            <a:ext cx="10604520" cy="441360"/>
           </a:xfrm>
           <a:prstGeom prst="rect">
             <a:avLst/>
@@ -17828,7 +17858,7 @@
         <p:spPr>
           <a:xfrm>
             <a:off x="768240" y="1170360"/>
-            <a:ext cx="1369440" cy="42120"/>
+            <a:ext cx="1369080" cy="41760"/>
           </a:xfrm>
           <a:prstGeom prst="rect">
             <a:avLst/>
@@ -17869,7 +17899,7 @@
         <p:spPr>
           <a:xfrm>
             <a:off x="768240" y="1298520"/>
-            <a:ext cx="10604880" cy="227880"/>
+            <a:ext cx="10604520" cy="227880"/>
           </a:xfrm>
           <a:prstGeom prst="rect">
             <a:avLst/>
@@ -17921,7 +17951,7 @@
         <p:spPr>
           <a:xfrm>
             <a:off x="0" y="6437520"/>
-            <a:ext cx="12189600" cy="12960"/>
+            <a:ext cx="12189240" cy="12600"/>
           </a:xfrm>
           <a:prstGeom prst="rect">
             <a:avLst/>
@@ -17962,7 +17992,7 @@
         <p:spPr>
           <a:xfrm>
             <a:off x="768240" y="6473880"/>
-            <a:ext cx="8227440" cy="136800"/>
+            <a:ext cx="8227080" cy="136800"/>
           </a:xfrm>
           <a:prstGeom prst="rect">
             <a:avLst/>
@@ -18014,7 +18044,7 @@
         <p:spPr>
           <a:xfrm>
             <a:off x="10607040" y="6473880"/>
-            <a:ext cx="820800" cy="136800"/>
+            <a:ext cx="820440" cy="136800"/>
           </a:xfrm>
           <a:prstGeom prst="rect">
             <a:avLst/>
@@ -18066,7 +18096,7 @@
         <p:spPr>
           <a:xfrm>
             <a:off x="768240" y="1828800"/>
-            <a:ext cx="5392800" cy="1283760"/>
+            <a:ext cx="5392440" cy="1283760"/>
           </a:xfrm>
           <a:prstGeom prst="rect">
             <a:avLst/>
@@ -18233,7 +18263,7 @@
         <p:spPr>
           <a:xfrm>
             <a:off x="6400800" y="1783080"/>
-            <a:ext cx="5027040" cy="212760"/>
+            <a:ext cx="5026680" cy="212760"/>
           </a:xfrm>
           <a:prstGeom prst="rect">
             <a:avLst/>
@@ -19049,7 +19079,7 @@
         <p:spPr>
           <a:xfrm>
             <a:off x="768240" y="3931920"/>
-            <a:ext cx="5392800" cy="861840"/>
+            <a:ext cx="5392440" cy="861480"/>
           </a:xfrm>
           <a:prstGeom prst="roundRect">
             <a:avLst>
@@ -19206,7 +19236,7 @@
         <p:spPr>
           <a:xfrm>
             <a:off x="768240" y="5074920"/>
-            <a:ext cx="5392800" cy="729360"/>
+            <a:ext cx="5392440" cy="729000"/>
           </a:xfrm>
           <a:prstGeom prst="roundRect">
             <a:avLst>
@@ -19249,7 +19279,7 @@
         <p:spPr>
           <a:xfrm>
             <a:off x="768240" y="5074920"/>
-            <a:ext cx="48600" cy="729360"/>
+            <a:ext cx="48240" cy="729000"/>
           </a:xfrm>
           <a:prstGeom prst="rect">
             <a:avLst/>
@@ -19290,7 +19320,7 @@
         <p:spPr>
           <a:xfrm>
             <a:off x="1024200" y="5139720"/>
-            <a:ext cx="4935600" cy="638280"/>
+            <a:ext cx="4935240" cy="638280"/>
           </a:xfrm>
           <a:prstGeom prst="rect">
             <a:avLst/>
@@ -19410,7 +19440,7 @@
         <p:spPr>
           <a:xfrm>
             <a:off x="768240" y="420480"/>
-            <a:ext cx="10604880" cy="441360"/>
+            <a:ext cx="10604520" cy="441360"/>
           </a:xfrm>
           <a:prstGeom prst="rect">
             <a:avLst/>
@@ -19462,7 +19492,7 @@
         <p:spPr>
           <a:xfrm>
             <a:off x="768240" y="1170360"/>
-            <a:ext cx="1369440" cy="42120"/>
+            <a:ext cx="1369080" cy="41760"/>
           </a:xfrm>
           <a:prstGeom prst="rect">
             <a:avLst/>
@@ -19503,7 +19533,7 @@
         <p:spPr>
           <a:xfrm>
             <a:off x="768240" y="1298520"/>
-            <a:ext cx="10604880" cy="227880"/>
+            <a:ext cx="10604520" cy="227880"/>
           </a:xfrm>
           <a:prstGeom prst="rect">
             <a:avLst/>
@@ -19555,7 +19585,7 @@
         <p:spPr>
           <a:xfrm>
             <a:off x="0" y="6437520"/>
-            <a:ext cx="12189600" cy="12960"/>
+            <a:ext cx="12189240" cy="12600"/>
           </a:xfrm>
           <a:prstGeom prst="rect">
             <a:avLst/>
@@ -19596,7 +19626,7 @@
         <p:spPr>
           <a:xfrm>
             <a:off x="768240" y="6473880"/>
-            <a:ext cx="8227440" cy="136800"/>
+            <a:ext cx="8227080" cy="136800"/>
           </a:xfrm>
           <a:prstGeom prst="rect">
             <a:avLst/>
@@ -19648,7 +19678,7 @@
         <p:spPr>
           <a:xfrm>
             <a:off x="10607040" y="6473880"/>
-            <a:ext cx="820800" cy="136800"/>
+            <a:ext cx="820440" cy="136800"/>
           </a:xfrm>
           <a:prstGeom prst="rect">
             <a:avLst/>
@@ -19700,7 +19730,7 @@
         <p:spPr>
           <a:xfrm>
             <a:off x="768240" y="1828800"/>
-            <a:ext cx="5850000" cy="2027880"/>
+            <a:ext cx="5849640" cy="2027520"/>
           </a:xfrm>
           <a:prstGeom prst="roundRect">
             <a:avLst>
@@ -20012,7 +20042,7 @@
         <p:spPr>
           <a:xfrm>
             <a:off x="6446520" y="1783080"/>
-            <a:ext cx="4935600" cy="212760"/>
+            <a:ext cx="4935240" cy="212760"/>
           </a:xfrm>
           <a:prstGeom prst="rect">
             <a:avLst/>
@@ -20064,7 +20094,7 @@
         <p:spPr>
           <a:xfrm>
             <a:off x="6446520" y="2148840"/>
-            <a:ext cx="4935600" cy="1218960"/>
+            <a:ext cx="4935240" cy="1218960"/>
           </a:xfrm>
           <a:prstGeom prst="rect">
             <a:avLst/>
@@ -20231,7 +20261,7 @@
         <p:spPr>
           <a:xfrm>
             <a:off x="768240" y="4343400"/>
-            <a:ext cx="10650600" cy="1095120"/>
+            <a:ext cx="10650240" cy="1094760"/>
           </a:xfrm>
           <a:prstGeom prst="roundRect">
             <a:avLst>
@@ -20274,7 +20304,7 @@
         <p:spPr>
           <a:xfrm>
             <a:off x="768240" y="4343400"/>
-            <a:ext cx="48600" cy="1095120"/>
+            <a:ext cx="48240" cy="1094760"/>
           </a:xfrm>
           <a:prstGeom prst="rect">
             <a:avLst/>
@@ -20315,7 +20345,7 @@
         <p:spPr>
           <a:xfrm>
             <a:off x="1024200" y="4590360"/>
-            <a:ext cx="10193400" cy="638280"/>
+            <a:ext cx="10193040" cy="638280"/>
           </a:xfrm>
           <a:prstGeom prst="rect">
             <a:avLst/>
@@ -20435,7 +20465,7 @@
         <p:spPr>
           <a:xfrm>
             <a:off x="768240" y="420480"/>
-            <a:ext cx="10604880" cy="441360"/>
+            <a:ext cx="10604520" cy="441360"/>
           </a:xfrm>
           <a:prstGeom prst="rect">
             <a:avLst/>
@@ -20487,7 +20517,7 @@
         <p:spPr>
           <a:xfrm>
             <a:off x="768240" y="1170360"/>
-            <a:ext cx="1369440" cy="42120"/>
+            <a:ext cx="1369080" cy="41760"/>
           </a:xfrm>
           <a:prstGeom prst="rect">
             <a:avLst/>
@@ -20528,7 +20558,7 @@
         <p:spPr>
           <a:xfrm>
             <a:off x="768240" y="1298520"/>
-            <a:ext cx="10604880" cy="227880"/>
+            <a:ext cx="10604520" cy="227880"/>
           </a:xfrm>
           <a:prstGeom prst="rect">
             <a:avLst/>
@@ -20580,7 +20610,7 @@
         <p:spPr>
           <a:xfrm>
             <a:off x="0" y="6437520"/>
-            <a:ext cx="12189600" cy="12960"/>
+            <a:ext cx="12189240" cy="12600"/>
           </a:xfrm>
           <a:prstGeom prst="rect">
             <a:avLst/>
@@ -20621,7 +20651,7 @@
         <p:spPr>
           <a:xfrm>
             <a:off x="768240" y="6473880"/>
-            <a:ext cx="8227440" cy="136800"/>
+            <a:ext cx="8227080" cy="136800"/>
           </a:xfrm>
           <a:prstGeom prst="rect">
             <a:avLst/>
@@ -20673,7 +20703,7 @@
         <p:spPr>
           <a:xfrm>
             <a:off x="10607040" y="6473880"/>
-            <a:ext cx="820800" cy="136800"/>
+            <a:ext cx="820440" cy="136800"/>
           </a:xfrm>
           <a:prstGeom prst="rect">
             <a:avLst/>
@@ -20725,7 +20755,7 @@
         <p:spPr>
           <a:xfrm>
             <a:off x="768240" y="1828800"/>
-            <a:ext cx="5850000" cy="2027880"/>
+            <a:ext cx="5849640" cy="2027520"/>
           </a:xfrm>
           <a:prstGeom prst="roundRect">
             <a:avLst>
@@ -21037,7 +21067,7 @@
         <p:spPr>
           <a:xfrm>
             <a:off x="6446520" y="1783080"/>
-            <a:ext cx="4935600" cy="197640"/>
+            <a:ext cx="4935240" cy="197640"/>
           </a:xfrm>
           <a:prstGeom prst="rect">
             <a:avLst/>
@@ -21089,7 +21119,7 @@
         <p:spPr>
           <a:xfrm>
             <a:off x="6446520" y="2194560"/>
-            <a:ext cx="4935600" cy="1328400"/>
+            <a:ext cx="4935240" cy="1328040"/>
           </a:xfrm>
           <a:prstGeom prst="roundRect">
             <a:avLst>
@@ -21288,7 +21318,7 @@
         <p:spPr>
           <a:xfrm>
             <a:off x="768240" y="4343400"/>
-            <a:ext cx="10650600" cy="1095120"/>
+            <a:ext cx="10650240" cy="1094760"/>
           </a:xfrm>
           <a:prstGeom prst="roundRect">
             <a:avLst>
@@ -21331,7 +21361,7 @@
         <p:spPr>
           <a:xfrm>
             <a:off x="768240" y="4343400"/>
-            <a:ext cx="48600" cy="1095120"/>
+            <a:ext cx="48240" cy="1094760"/>
           </a:xfrm>
           <a:prstGeom prst="rect">
             <a:avLst/>
@@ -21372,7 +21402,7 @@
         <p:spPr>
           <a:xfrm>
             <a:off x="1024200" y="4590360"/>
-            <a:ext cx="10193400" cy="638280"/>
+            <a:ext cx="10193040" cy="638280"/>
           </a:xfrm>
           <a:prstGeom prst="rect">
             <a:avLst/>
@@ -21492,7 +21522,7 @@
         <p:spPr>
           <a:xfrm>
             <a:off x="768240" y="420480"/>
-            <a:ext cx="10604880" cy="441360"/>
+            <a:ext cx="10604520" cy="441360"/>
           </a:xfrm>
           <a:prstGeom prst="rect">
             <a:avLst/>
@@ -21544,7 +21574,7 @@
         <p:spPr>
           <a:xfrm>
             <a:off x="768240" y="1170360"/>
-            <a:ext cx="1369440" cy="42120"/>
+            <a:ext cx="1369080" cy="41760"/>
           </a:xfrm>
           <a:prstGeom prst="rect">
             <a:avLst/>
@@ -21585,7 +21615,7 @@
         <p:spPr>
           <a:xfrm>
             <a:off x="768240" y="1298520"/>
-            <a:ext cx="10604880" cy="227880"/>
+            <a:ext cx="10604520" cy="227880"/>
           </a:xfrm>
           <a:prstGeom prst="rect">
             <a:avLst/>
@@ -21637,7 +21667,7 @@
         <p:spPr>
           <a:xfrm>
             <a:off x="0" y="6437520"/>
-            <a:ext cx="12189600" cy="12960"/>
+            <a:ext cx="12189240" cy="12600"/>
           </a:xfrm>
           <a:prstGeom prst="rect">
             <a:avLst/>
@@ -21678,7 +21708,7 @@
         <p:spPr>
           <a:xfrm>
             <a:off x="768240" y="6473880"/>
-            <a:ext cx="8227440" cy="136800"/>
+            <a:ext cx="8227080" cy="136800"/>
           </a:xfrm>
           <a:prstGeom prst="rect">
             <a:avLst/>
@@ -21730,7 +21760,7 @@
         <p:spPr>
           <a:xfrm>
             <a:off x="10607040" y="6473880"/>
-            <a:ext cx="820800" cy="136800"/>
+            <a:ext cx="820440" cy="136800"/>
           </a:xfrm>
           <a:prstGeom prst="rect">
             <a:avLst/>
@@ -21782,7 +21812,7 @@
         <p:spPr>
           <a:xfrm>
             <a:off x="768240" y="1828800"/>
-            <a:ext cx="5392800" cy="212760"/>
+            <a:ext cx="5392440" cy="212760"/>
           </a:xfrm>
           <a:prstGeom prst="rect">
             <a:avLst/>
@@ -21834,7 +21864,7 @@
         <p:spPr>
           <a:xfrm>
             <a:off x="768240" y="2240280"/>
-            <a:ext cx="5392800" cy="473400"/>
+            <a:ext cx="5392440" cy="473040"/>
           </a:xfrm>
           <a:prstGeom prst="roundRect">
             <a:avLst>
@@ -21877,7 +21907,7 @@
         <p:spPr>
           <a:xfrm>
             <a:off x="768240" y="2240280"/>
-            <a:ext cx="48600" cy="473400"/>
+            <a:ext cx="48240" cy="473040"/>
           </a:xfrm>
           <a:prstGeom prst="rect">
             <a:avLst/>
@@ -21918,7 +21948,7 @@
         <p:spPr>
           <a:xfrm>
             <a:off x="996840" y="2383200"/>
-            <a:ext cx="1460880" cy="197280"/>
+            <a:ext cx="1460520" cy="197280"/>
           </a:xfrm>
           <a:prstGeom prst="rect">
             <a:avLst/>
@@ -21970,7 +22000,7 @@
         <p:spPr>
           <a:xfrm>
             <a:off x="2368440" y="2389680"/>
-            <a:ext cx="3701160" cy="174600"/>
+            <a:ext cx="3700800" cy="174600"/>
           </a:xfrm>
           <a:prstGeom prst="rect">
             <a:avLst/>
@@ -22022,7 +22052,7 @@
         <p:spPr>
           <a:xfrm>
             <a:off x="768240" y="2807280"/>
-            <a:ext cx="5392800" cy="473400"/>
+            <a:ext cx="5392440" cy="473040"/>
           </a:xfrm>
           <a:prstGeom prst="roundRect">
             <a:avLst>
@@ -22065,7 +22095,7 @@
         <p:spPr>
           <a:xfrm>
             <a:off x="768240" y="2807280"/>
-            <a:ext cx="48600" cy="473400"/>
+            <a:ext cx="48240" cy="473040"/>
           </a:xfrm>
           <a:prstGeom prst="rect">
             <a:avLst/>
@@ -22106,7 +22136,7 @@
         <p:spPr>
           <a:xfrm>
             <a:off x="996840" y="2949840"/>
-            <a:ext cx="1460880" cy="197280"/>
+            <a:ext cx="1460520" cy="197280"/>
           </a:xfrm>
           <a:prstGeom prst="rect">
             <a:avLst/>
@@ -22158,7 +22188,7 @@
         <p:spPr>
           <a:xfrm>
             <a:off x="2368440" y="2956680"/>
-            <a:ext cx="3701160" cy="174600"/>
+            <a:ext cx="3700800" cy="174600"/>
           </a:xfrm>
           <a:prstGeom prst="rect">
             <a:avLst/>
@@ -22210,7 +22240,7 @@
         <p:spPr>
           <a:xfrm>
             <a:off x="768240" y="3374280"/>
-            <a:ext cx="5392800" cy="473400"/>
+            <a:ext cx="5392440" cy="473040"/>
           </a:xfrm>
           <a:prstGeom prst="roundRect">
             <a:avLst>
@@ -22253,7 +22283,7 @@
         <p:spPr>
           <a:xfrm>
             <a:off x="768240" y="3374280"/>
-            <a:ext cx="48600" cy="473400"/>
+            <a:ext cx="48240" cy="473040"/>
           </a:xfrm>
           <a:prstGeom prst="rect">
             <a:avLst/>
@@ -22294,7 +22324,7 @@
         <p:spPr>
           <a:xfrm>
             <a:off x="996840" y="3516840"/>
-            <a:ext cx="1460880" cy="197280"/>
+            <a:ext cx="1460520" cy="197280"/>
           </a:xfrm>
           <a:prstGeom prst="rect">
             <a:avLst/>
@@ -22346,7 +22376,7 @@
         <p:spPr>
           <a:xfrm>
             <a:off x="2368440" y="3523680"/>
-            <a:ext cx="3701160" cy="174600"/>
+            <a:ext cx="3700800" cy="174600"/>
           </a:xfrm>
           <a:prstGeom prst="rect">
             <a:avLst/>
@@ -23268,7 +23298,7 @@
         <p:spPr>
           <a:xfrm>
             <a:off x="768240" y="4434840"/>
-            <a:ext cx="5392800" cy="1003680"/>
+            <a:ext cx="5392440" cy="1003320"/>
           </a:xfrm>
           <a:prstGeom prst="roundRect">
             <a:avLst>
@@ -23311,7 +23341,7 @@
         <p:spPr>
           <a:xfrm>
             <a:off x="768240" y="4434840"/>
-            <a:ext cx="48600" cy="1003680"/>
+            <a:ext cx="48240" cy="1003320"/>
           </a:xfrm>
           <a:prstGeom prst="rect">
             <a:avLst/>
@@ -23352,7 +23382,7 @@
         <p:spPr>
           <a:xfrm>
             <a:off x="1024200" y="4636080"/>
-            <a:ext cx="4935600" cy="638280"/>
+            <a:ext cx="4935240" cy="638280"/>
           </a:xfrm>
           <a:prstGeom prst="rect">
             <a:avLst/>
@@ -23472,7 +23502,7 @@
         <p:spPr>
           <a:xfrm>
             <a:off x="768240" y="2240280"/>
-            <a:ext cx="1826640" cy="974880"/>
+            <a:ext cx="1826280" cy="974880"/>
           </a:xfrm>
           <a:prstGeom prst="rect">
             <a:avLst/>
@@ -23524,7 +23554,7 @@
         <p:spPr>
           <a:xfrm>
             <a:off x="768240" y="3246120"/>
-            <a:ext cx="1826640" cy="48600"/>
+            <a:ext cx="1826280" cy="48240"/>
           </a:xfrm>
           <a:prstGeom prst="rect">
             <a:avLst/>
@@ -23565,7 +23595,7 @@
         <p:spPr>
           <a:xfrm>
             <a:off x="768240" y="3429000"/>
-            <a:ext cx="10422000" cy="639360"/>
+            <a:ext cx="10421640" cy="639360"/>
           </a:xfrm>
           <a:prstGeom prst="rect">
             <a:avLst/>
@@ -23617,7 +23647,7 @@
         <p:spPr>
           <a:xfrm>
             <a:off x="768240" y="4754880"/>
-            <a:ext cx="7313040" cy="243000"/>
+            <a:ext cx="7312680" cy="243000"/>
           </a:xfrm>
           <a:prstGeom prst="rect">
             <a:avLst/>
@@ -23706,7 +23736,7 @@
         <p:spPr>
           <a:xfrm>
             <a:off x="768240" y="420480"/>
-            <a:ext cx="10604880" cy="441360"/>
+            <a:ext cx="10604520" cy="441360"/>
           </a:xfrm>
           <a:prstGeom prst="rect">
             <a:avLst/>
@@ -23758,7 +23788,7 @@
         <p:spPr>
           <a:xfrm>
             <a:off x="768240" y="1170360"/>
-            <a:ext cx="1369440" cy="42120"/>
+            <a:ext cx="1369080" cy="41760"/>
           </a:xfrm>
           <a:prstGeom prst="rect">
             <a:avLst/>
@@ -23799,7 +23829,7 @@
         <p:spPr>
           <a:xfrm>
             <a:off x="0" y="6437520"/>
-            <a:ext cx="12189600" cy="12960"/>
+            <a:ext cx="12189240" cy="12600"/>
           </a:xfrm>
           <a:prstGeom prst="rect">
             <a:avLst/>
@@ -23840,7 +23870,7 @@
         <p:spPr>
           <a:xfrm>
             <a:off x="768240" y="6473880"/>
-            <a:ext cx="8227440" cy="136800"/>
+            <a:ext cx="8227080" cy="136800"/>
           </a:xfrm>
           <a:prstGeom prst="rect">
             <a:avLst/>
@@ -23892,7 +23922,7 @@
         <p:spPr>
           <a:xfrm>
             <a:off x="10607040" y="6473880"/>
-            <a:ext cx="820800" cy="136800"/>
+            <a:ext cx="820440" cy="136800"/>
           </a:xfrm>
           <a:prstGeom prst="rect">
             <a:avLst/>
@@ -23944,7 +23974,7 @@
         <p:spPr>
           <a:xfrm>
             <a:off x="768240" y="1417320"/>
-            <a:ext cx="5575680" cy="2321640"/>
+            <a:ext cx="5575320" cy="2321640"/>
           </a:xfrm>
           <a:prstGeom prst="rect">
             <a:avLst/>
@@ -24213,7 +24243,7 @@
         <p:spPr>
           <a:xfrm>
             <a:off x="6583680" y="1371600"/>
-            <a:ext cx="4844160" cy="212760"/>
+            <a:ext cx="4843800" cy="212760"/>
           </a:xfrm>
           <a:prstGeom prst="rect">
             <a:avLst/>
@@ -24265,7 +24295,7 @@
         <p:spPr>
           <a:xfrm>
             <a:off x="6583680" y="1783080"/>
-            <a:ext cx="4844160" cy="1218960"/>
+            <a:ext cx="4843800" cy="1218960"/>
           </a:xfrm>
           <a:prstGeom prst="rect">
             <a:avLst/>
@@ -24432,7 +24462,7 @@
         <p:spPr>
           <a:xfrm>
             <a:off x="6583680" y="4069080"/>
-            <a:ext cx="4844160" cy="866520"/>
+            <a:ext cx="4843800" cy="866160"/>
           </a:xfrm>
           <a:prstGeom prst="roundRect">
             <a:avLst>
@@ -24475,7 +24505,7 @@
         <p:spPr>
           <a:xfrm>
             <a:off x="6583680" y="4069080"/>
-            <a:ext cx="48600" cy="866520"/>
+            <a:ext cx="48240" cy="866160"/>
           </a:xfrm>
           <a:prstGeom prst="rect">
             <a:avLst/>
@@ -24516,7 +24546,7 @@
         <p:spPr>
           <a:xfrm>
             <a:off x="6839640" y="4305600"/>
-            <a:ext cx="4386960" cy="430560"/>
+            <a:ext cx="4386600" cy="430560"/>
           </a:xfrm>
           <a:prstGeom prst="rect">
             <a:avLst/>
@@ -24636,7 +24666,7 @@
         <p:spPr>
           <a:xfrm>
             <a:off x="768240" y="420480"/>
-            <a:ext cx="10604880" cy="441360"/>
+            <a:ext cx="10604520" cy="441360"/>
           </a:xfrm>
           <a:prstGeom prst="rect">
             <a:avLst/>
@@ -24688,7 +24718,7 @@
         <p:spPr>
           <a:xfrm>
             <a:off x="768240" y="1170360"/>
-            <a:ext cx="1369440" cy="42120"/>
+            <a:ext cx="1369080" cy="41760"/>
           </a:xfrm>
           <a:prstGeom prst="rect">
             <a:avLst/>
@@ -24729,7 +24759,7 @@
         <p:spPr>
           <a:xfrm>
             <a:off x="0" y="6437520"/>
-            <a:ext cx="12189600" cy="12960"/>
+            <a:ext cx="12189240" cy="12600"/>
           </a:xfrm>
           <a:prstGeom prst="rect">
             <a:avLst/>
@@ -24770,7 +24800,7 @@
         <p:spPr>
           <a:xfrm>
             <a:off x="768240" y="6473880"/>
-            <a:ext cx="8227440" cy="136800"/>
+            <a:ext cx="8227080" cy="136800"/>
           </a:xfrm>
           <a:prstGeom prst="rect">
             <a:avLst/>
@@ -24822,7 +24852,7 @@
         <p:spPr>
           <a:xfrm>
             <a:off x="10607040" y="6473880"/>
-            <a:ext cx="820800" cy="136800"/>
+            <a:ext cx="820440" cy="136800"/>
           </a:xfrm>
           <a:prstGeom prst="rect">
             <a:avLst/>
@@ -24874,7 +24904,7 @@
         <p:spPr>
           <a:xfrm>
             <a:off x="768240" y="1417320"/>
-            <a:ext cx="3426840" cy="3655440"/>
+            <a:ext cx="3426480" cy="3655080"/>
           </a:xfrm>
           <a:prstGeom prst="roundRect">
             <a:avLst>
@@ -24917,7 +24947,7 @@
         <p:spPr>
           <a:xfrm>
             <a:off x="768240" y="1417320"/>
-            <a:ext cx="3426840" cy="500760"/>
+            <a:ext cx="3426480" cy="500400"/>
           </a:xfrm>
           <a:prstGeom prst="roundRect">
             <a:avLst>
@@ -24960,7 +24990,7 @@
         <p:spPr>
           <a:xfrm>
             <a:off x="768240" y="1490400"/>
-            <a:ext cx="3426840" cy="227880"/>
+            <a:ext cx="3426480" cy="227880"/>
           </a:xfrm>
           <a:prstGeom prst="rect">
             <a:avLst/>
@@ -25012,7 +25042,7 @@
         <p:spPr>
           <a:xfrm>
             <a:off x="996840" y="2103120"/>
-            <a:ext cx="3015360" cy="1232280"/>
+            <a:ext cx="3015000" cy="1232280"/>
           </a:xfrm>
           <a:prstGeom prst="rect">
             <a:avLst/>
@@ -25179,7 +25209,7 @@
         <p:spPr>
           <a:xfrm>
             <a:off x="4380120" y="1417320"/>
-            <a:ext cx="3426840" cy="3655440"/>
+            <a:ext cx="3426480" cy="3655080"/>
           </a:xfrm>
           <a:prstGeom prst="roundRect">
             <a:avLst>
@@ -25222,7 +25252,7 @@
         <p:spPr>
           <a:xfrm>
             <a:off x="4380120" y="1417320"/>
-            <a:ext cx="3426840" cy="500760"/>
+            <a:ext cx="3426480" cy="500400"/>
           </a:xfrm>
           <a:prstGeom prst="roundRect">
             <a:avLst>
@@ -25265,7 +25295,7 @@
         <p:spPr>
           <a:xfrm>
             <a:off x="4380120" y="1490400"/>
-            <a:ext cx="3426840" cy="227880"/>
+            <a:ext cx="3426480" cy="227880"/>
           </a:xfrm>
           <a:prstGeom prst="rect">
             <a:avLst/>
@@ -25317,7 +25347,7 @@
         <p:spPr>
           <a:xfrm>
             <a:off x="4608720" y="2103120"/>
-            <a:ext cx="3015360" cy="1232280"/>
+            <a:ext cx="3015000" cy="1232280"/>
           </a:xfrm>
           <a:prstGeom prst="rect">
             <a:avLst/>
@@ -25484,7 +25514,7 @@
         <p:spPr>
           <a:xfrm>
             <a:off x="7992000" y="1417320"/>
-            <a:ext cx="3426840" cy="3655440"/>
+            <a:ext cx="3426480" cy="3655080"/>
           </a:xfrm>
           <a:prstGeom prst="roundRect">
             <a:avLst>
@@ -25527,7 +25557,7 @@
         <p:spPr>
           <a:xfrm>
             <a:off x="7992000" y="1417320"/>
-            <a:ext cx="3426840" cy="500760"/>
+            <a:ext cx="3426480" cy="500400"/>
           </a:xfrm>
           <a:prstGeom prst="roundRect">
             <a:avLst>
@@ -25570,7 +25600,7 @@
         <p:spPr>
           <a:xfrm>
             <a:off x="7992000" y="1490400"/>
-            <a:ext cx="3426840" cy="227880"/>
+            <a:ext cx="3426480" cy="227880"/>
           </a:xfrm>
           <a:prstGeom prst="rect">
             <a:avLst/>
@@ -25622,7 +25652,7 @@
         <p:spPr>
           <a:xfrm>
             <a:off x="8220600" y="2103120"/>
-            <a:ext cx="3015360" cy="1232280"/>
+            <a:ext cx="3015000" cy="1232280"/>
           </a:xfrm>
           <a:prstGeom prst="rect">
             <a:avLst/>
@@ -25789,7 +25819,7 @@
         <p:spPr>
           <a:xfrm>
             <a:off x="768240" y="5212080"/>
-            <a:ext cx="10650600" cy="500760"/>
+            <a:ext cx="10650240" cy="500400"/>
           </a:xfrm>
           <a:prstGeom prst="roundRect">
             <a:avLst>
@@ -25832,7 +25862,7 @@
         <p:spPr>
           <a:xfrm>
             <a:off x="768240" y="5212080"/>
-            <a:ext cx="48600" cy="500760"/>
+            <a:ext cx="48240" cy="500400"/>
           </a:xfrm>
           <a:prstGeom prst="rect">
             <a:avLst/>
@@ -25873,7 +25903,7 @@
         <p:spPr>
           <a:xfrm>
             <a:off x="1024200" y="5377320"/>
-            <a:ext cx="10193400" cy="207000"/>
+            <a:ext cx="10193040" cy="207000"/>
           </a:xfrm>
           <a:prstGeom prst="rect">
             <a:avLst/>
@@ -25962,7 +25992,7 @@
         <p:spPr>
           <a:xfrm>
             <a:off x="0" y="2606040"/>
-            <a:ext cx="1826640" cy="61200"/>
+            <a:ext cx="1826280" cy="60840"/>
           </a:xfrm>
           <a:prstGeom prst="rect">
             <a:avLst/>
@@ -26003,7 +26033,7 @@
         <p:spPr>
           <a:xfrm>
             <a:off x="768240" y="2788920"/>
-            <a:ext cx="10422000" cy="822600"/>
+            <a:ext cx="10421640" cy="822600"/>
           </a:xfrm>
           <a:prstGeom prst="rect">
             <a:avLst/>
@@ -26055,7 +26085,7 @@
         <p:spPr>
           <a:xfrm>
             <a:off x="768240" y="3977640"/>
-            <a:ext cx="10056240" cy="304560"/>
+            <a:ext cx="10055880" cy="304560"/>
           </a:xfrm>
           <a:prstGeom prst="rect">
             <a:avLst/>
@@ -26107,7 +26137,7 @@
         <p:spPr>
           <a:xfrm>
             <a:off x="768240" y="4754880"/>
-            <a:ext cx="10056240" cy="273960"/>
+            <a:ext cx="10055880" cy="273960"/>
           </a:xfrm>
           <a:prstGeom prst="rect">
             <a:avLst/>
@@ -26159,7 +26189,7 @@
         <p:spPr>
           <a:xfrm>
             <a:off x="768240" y="5852160"/>
-            <a:ext cx="7313040" cy="197640"/>
+            <a:ext cx="7312680" cy="197640"/>
           </a:xfrm>
           <a:prstGeom prst="rect">
             <a:avLst/>
@@ -26194,7 +26224,7 @@
                 <a:latin typeface="Arial"/>
                 <a:ea typeface="DejaVu Sans"/>
               </a:rPr>
-              <a:t>Radlab Developer Services · DSS 2026 AI Edition</a:t>
+              <a:t>radlab.dev · DSS 2026 AI Edition</a:t>
             </a:r>
             <a:endParaRPr b="0" lang="pl-PL" sz="1300" spc="-1" strike="noStrike">
               <a:latin typeface="Arial"/>
@@ -26215,7 +26245,7 @@
         <p:spPr>
           <a:xfrm>
             <a:off x="11016000" y="6170400"/>
-            <a:ext cx="1061280" cy="596520"/>
+            <a:ext cx="1060920" cy="596160"/>
           </a:xfrm>
           <a:prstGeom prst="rect">
             <a:avLst/>
@@ -26271,7 +26301,7 @@
         <p:spPr>
           <a:xfrm>
             <a:off x="768240" y="420480"/>
-            <a:ext cx="10604880" cy="441360"/>
+            <a:ext cx="10604520" cy="441360"/>
           </a:xfrm>
           <a:prstGeom prst="rect">
             <a:avLst/>
@@ -26323,7 +26353,7 @@
         <p:spPr>
           <a:xfrm>
             <a:off x="768240" y="1170360"/>
-            <a:ext cx="1369440" cy="42120"/>
+            <a:ext cx="1369080" cy="41760"/>
           </a:xfrm>
           <a:prstGeom prst="rect">
             <a:avLst/>
@@ -26364,7 +26394,7 @@
         <p:spPr>
           <a:xfrm>
             <a:off x="0" y="6437520"/>
-            <a:ext cx="12189600" cy="12960"/>
+            <a:ext cx="12189240" cy="12600"/>
           </a:xfrm>
           <a:prstGeom prst="rect">
             <a:avLst/>
@@ -26405,7 +26435,7 @@
         <p:spPr>
           <a:xfrm>
             <a:off x="768240" y="6473880"/>
-            <a:ext cx="8227440" cy="136800"/>
+            <a:ext cx="8227080" cy="136800"/>
           </a:xfrm>
           <a:prstGeom prst="rect">
             <a:avLst/>
@@ -26457,7 +26487,7 @@
         <p:spPr>
           <a:xfrm>
             <a:off x="10607040" y="6473880"/>
-            <a:ext cx="820800" cy="136800"/>
+            <a:ext cx="820440" cy="136800"/>
           </a:xfrm>
           <a:prstGeom prst="rect">
             <a:avLst/>
@@ -26509,7 +26539,7 @@
         <p:spPr>
           <a:xfrm>
             <a:off x="768240" y="1417320"/>
-            <a:ext cx="10604880" cy="621720"/>
+            <a:ext cx="10604520" cy="621720"/>
           </a:xfrm>
           <a:prstGeom prst="rect">
             <a:avLst/>
@@ -26561,7 +26591,7 @@
         <p:spPr>
           <a:xfrm>
             <a:off x="768240" y="2423160"/>
-            <a:ext cx="5484240" cy="1958760"/>
+            <a:ext cx="5483880" cy="1958760"/>
           </a:xfrm>
           <a:prstGeom prst="rect">
             <a:avLst/>
@@ -26762,7 +26792,7 @@
         <p:spPr>
           <a:xfrm>
             <a:off x="6583680" y="2423160"/>
-            <a:ext cx="4844160" cy="2375280"/>
+            <a:ext cx="4843800" cy="2374920"/>
           </a:xfrm>
           <a:prstGeom prst="roundRect">
             <a:avLst>
@@ -26805,7 +26835,7 @@
         <p:spPr>
           <a:xfrm>
             <a:off x="6583680" y="2423160"/>
-            <a:ext cx="48600" cy="2375280"/>
+            <a:ext cx="48240" cy="2374920"/>
           </a:xfrm>
           <a:prstGeom prst="rect">
             <a:avLst/>
@@ -26846,7 +26876,7 @@
         <p:spPr>
           <a:xfrm>
             <a:off x="6839640" y="3206160"/>
-            <a:ext cx="4386960" cy="846000"/>
+            <a:ext cx="4386600" cy="846000"/>
           </a:xfrm>
           <a:prstGeom prst="rect">
             <a:avLst/>
@@ -26929,7 +26959,7 @@
         <p:spPr>
           <a:xfrm>
             <a:off x="6583680" y="4983480"/>
-            <a:ext cx="4844160" cy="197640"/>
+            <a:ext cx="4843800" cy="197640"/>
           </a:xfrm>
           <a:prstGeom prst="rect">
             <a:avLst/>
@@ -27018,7 +27048,7 @@
         <p:spPr>
           <a:xfrm>
             <a:off x="768240" y="2240280"/>
-            <a:ext cx="1826640" cy="974880"/>
+            <a:ext cx="1826280" cy="974880"/>
           </a:xfrm>
           <a:prstGeom prst="rect">
             <a:avLst/>
@@ -27070,7 +27100,7 @@
         <p:spPr>
           <a:xfrm>
             <a:off x="768240" y="3246120"/>
-            <a:ext cx="1826640" cy="48600"/>
+            <a:ext cx="1826280" cy="48240"/>
           </a:xfrm>
           <a:prstGeom prst="rect">
             <a:avLst/>
@@ -27111,7 +27141,7 @@
         <p:spPr>
           <a:xfrm>
             <a:off x="768240" y="3429000"/>
-            <a:ext cx="10422000" cy="639360"/>
+            <a:ext cx="10421640" cy="639360"/>
           </a:xfrm>
           <a:prstGeom prst="rect">
             <a:avLst/>
@@ -27163,7 +27193,7 @@
         <p:spPr>
           <a:xfrm>
             <a:off x="768240" y="4754880"/>
-            <a:ext cx="7313040" cy="243000"/>
+            <a:ext cx="7312680" cy="243000"/>
           </a:xfrm>
           <a:prstGeom prst="rect">
             <a:avLst/>
@@ -27252,7 +27282,7 @@
         <p:spPr>
           <a:xfrm>
             <a:off x="768240" y="420480"/>
-            <a:ext cx="10604880" cy="441360"/>
+            <a:ext cx="10604520" cy="441360"/>
           </a:xfrm>
           <a:prstGeom prst="rect">
             <a:avLst/>
@@ -27304,7 +27334,7 @@
         <p:spPr>
           <a:xfrm>
             <a:off x="768240" y="1170360"/>
-            <a:ext cx="1369440" cy="42120"/>
+            <a:ext cx="1369080" cy="41760"/>
           </a:xfrm>
           <a:prstGeom prst="rect">
             <a:avLst/>
@@ -27345,7 +27375,7 @@
         <p:spPr>
           <a:xfrm>
             <a:off x="0" y="6437520"/>
-            <a:ext cx="12189600" cy="12960"/>
+            <a:ext cx="12189240" cy="12600"/>
           </a:xfrm>
           <a:prstGeom prst="rect">
             <a:avLst/>
@@ -27386,7 +27416,7 @@
         <p:spPr>
           <a:xfrm>
             <a:off x="768240" y="6473880"/>
-            <a:ext cx="8227440" cy="136800"/>
+            <a:ext cx="8227080" cy="136800"/>
           </a:xfrm>
           <a:prstGeom prst="rect">
             <a:avLst/>
@@ -27438,7 +27468,7 @@
         <p:spPr>
           <a:xfrm>
             <a:off x="10607040" y="6473880"/>
-            <a:ext cx="820800" cy="136800"/>
+            <a:ext cx="820440" cy="136800"/>
           </a:xfrm>
           <a:prstGeom prst="rect">
             <a:avLst/>
@@ -27490,7 +27520,7 @@
         <p:spPr>
           <a:xfrm>
             <a:off x="768240" y="1417320"/>
-            <a:ext cx="5255640" cy="3564000"/>
+            <a:ext cx="5255280" cy="3563640"/>
           </a:xfrm>
           <a:prstGeom prst="roundRect">
             <a:avLst>
@@ -27536,7 +27566,7 @@
         <p:spPr>
           <a:xfrm>
             <a:off x="768240" y="1417320"/>
-            <a:ext cx="5255640" cy="546480"/>
+            <a:ext cx="5255280" cy="546120"/>
           </a:xfrm>
           <a:prstGeom prst="roundRect">
             <a:avLst>
@@ -27579,7 +27609,7 @@
         <p:spPr>
           <a:xfrm>
             <a:off x="768240" y="1472040"/>
-            <a:ext cx="5255640" cy="227880"/>
+            <a:ext cx="5255280" cy="227880"/>
           </a:xfrm>
           <a:prstGeom prst="rect">
             <a:avLst/>
@@ -27631,7 +27661,7 @@
         <p:spPr>
           <a:xfrm>
             <a:off x="996840" y="2148840"/>
-            <a:ext cx="1415160" cy="182160"/>
+            <a:ext cx="1414800" cy="182160"/>
           </a:xfrm>
           <a:prstGeom prst="rect">
             <a:avLst/>
@@ -27683,7 +27713,7 @@
         <p:spPr>
           <a:xfrm>
             <a:off x="2368440" y="2148840"/>
-            <a:ext cx="3472560" cy="190080"/>
+            <a:ext cx="3472200" cy="190080"/>
           </a:xfrm>
           <a:prstGeom prst="rect">
             <a:avLst/>
@@ -27745,7 +27775,7 @@
         <p:spPr>
           <a:xfrm>
             <a:off x="996840" y="2679120"/>
-            <a:ext cx="1415160" cy="182160"/>
+            <a:ext cx="1414800" cy="182160"/>
           </a:xfrm>
           <a:prstGeom prst="rect">
             <a:avLst/>
@@ -27797,7 +27827,7 @@
         <p:spPr>
           <a:xfrm>
             <a:off x="2368440" y="2679120"/>
-            <a:ext cx="3472560" cy="190080"/>
+            <a:ext cx="3472200" cy="190080"/>
           </a:xfrm>
           <a:prstGeom prst="rect">
             <a:avLst/>
@@ -27849,7 +27879,7 @@
         <p:spPr>
           <a:xfrm>
             <a:off x="996840" y="3209400"/>
-            <a:ext cx="1415160" cy="182160"/>
+            <a:ext cx="1414800" cy="182160"/>
           </a:xfrm>
           <a:prstGeom prst="rect">
             <a:avLst/>
@@ -27901,7 +27931,7 @@
         <p:spPr>
           <a:xfrm>
             <a:off x="2368440" y="3209400"/>
-            <a:ext cx="3472560" cy="190080"/>
+            <a:ext cx="3472200" cy="190080"/>
           </a:xfrm>
           <a:prstGeom prst="rect">
             <a:avLst/>
@@ -27953,7 +27983,7 @@
         <p:spPr>
           <a:xfrm>
             <a:off x="996840" y="3740040"/>
-            <a:ext cx="1415160" cy="182160"/>
+            <a:ext cx="1414800" cy="182160"/>
           </a:xfrm>
           <a:prstGeom prst="rect">
             <a:avLst/>
@@ -28005,7 +28035,7 @@
         <p:spPr>
           <a:xfrm>
             <a:off x="2368440" y="3740040"/>
-            <a:ext cx="3472560" cy="190080"/>
+            <a:ext cx="3472200" cy="190080"/>
           </a:xfrm>
           <a:prstGeom prst="rect">
             <a:avLst/>
@@ -28057,7 +28087,7 @@
         <p:spPr>
           <a:xfrm>
             <a:off x="996840" y="4270320"/>
-            <a:ext cx="1415160" cy="182160"/>
+            <a:ext cx="1414800" cy="182160"/>
           </a:xfrm>
           <a:prstGeom prst="rect">
             <a:avLst/>
@@ -28109,7 +28139,7 @@
         <p:spPr>
           <a:xfrm>
             <a:off x="2368440" y="4270320"/>
-            <a:ext cx="3472560" cy="190080"/>
+            <a:ext cx="3472200" cy="190080"/>
           </a:xfrm>
           <a:prstGeom prst="rect">
             <a:avLst/>
@@ -28161,7 +28191,7 @@
         <p:spPr>
           <a:xfrm>
             <a:off x="6400800" y="1417320"/>
-            <a:ext cx="5255640" cy="3564000"/>
+            <a:ext cx="5255280" cy="3563640"/>
           </a:xfrm>
           <a:prstGeom prst="roundRect">
             <a:avLst>
@@ -28207,7 +28237,7 @@
         <p:spPr>
           <a:xfrm>
             <a:off x="6400800" y="1417320"/>
-            <a:ext cx="5255640" cy="546480"/>
+            <a:ext cx="5255280" cy="546120"/>
           </a:xfrm>
           <a:prstGeom prst="roundRect">
             <a:avLst>
@@ -28250,7 +28280,7 @@
         <p:spPr>
           <a:xfrm>
             <a:off x="6400800" y="1472040"/>
-            <a:ext cx="5255640" cy="227880"/>
+            <a:ext cx="5255280" cy="227880"/>
           </a:xfrm>
           <a:prstGeom prst="rect">
             <a:avLst/>
@@ -28302,7 +28332,7 @@
         <p:spPr>
           <a:xfrm>
             <a:off x="6629400" y="2148840"/>
-            <a:ext cx="1415160" cy="182160"/>
+            <a:ext cx="1414800" cy="182160"/>
           </a:xfrm>
           <a:prstGeom prst="rect">
             <a:avLst/>
@@ -28354,7 +28384,7 @@
         <p:spPr>
           <a:xfrm>
             <a:off x="8001000" y="2148840"/>
-            <a:ext cx="3472560" cy="190080"/>
+            <a:ext cx="3472200" cy="190080"/>
           </a:xfrm>
           <a:prstGeom prst="rect">
             <a:avLst/>
@@ -28406,7 +28436,7 @@
         <p:spPr>
           <a:xfrm>
             <a:off x="6629400" y="2679120"/>
-            <a:ext cx="1415160" cy="182160"/>
+            <a:ext cx="1414800" cy="182160"/>
           </a:xfrm>
           <a:prstGeom prst="rect">
             <a:avLst/>
@@ -28458,7 +28488,7 @@
         <p:spPr>
           <a:xfrm>
             <a:off x="8001000" y="2679120"/>
-            <a:ext cx="3472560" cy="190080"/>
+            <a:ext cx="3472200" cy="190080"/>
           </a:xfrm>
           <a:prstGeom prst="rect">
             <a:avLst/>
@@ -28510,7 +28540,7 @@
         <p:spPr>
           <a:xfrm>
             <a:off x="6629400" y="3209400"/>
-            <a:ext cx="1415160" cy="182160"/>
+            <a:ext cx="1414800" cy="182160"/>
           </a:xfrm>
           <a:prstGeom prst="rect">
             <a:avLst/>
@@ -28562,7 +28592,7 @@
         <p:spPr>
           <a:xfrm>
             <a:off x="8001000" y="3209400"/>
-            <a:ext cx="3472560" cy="190080"/>
+            <a:ext cx="3472200" cy="190080"/>
           </a:xfrm>
           <a:prstGeom prst="rect">
             <a:avLst/>
@@ -28614,7 +28644,7 @@
         <p:spPr>
           <a:xfrm>
             <a:off x="6629400" y="3740040"/>
-            <a:ext cx="1415160" cy="182160"/>
+            <a:ext cx="1414800" cy="182160"/>
           </a:xfrm>
           <a:prstGeom prst="rect">
             <a:avLst/>
@@ -28666,7 +28696,7 @@
         <p:spPr>
           <a:xfrm>
             <a:off x="8001000" y="3740040"/>
-            <a:ext cx="3472560" cy="190080"/>
+            <a:ext cx="3472200" cy="190080"/>
           </a:xfrm>
           <a:prstGeom prst="rect">
             <a:avLst/>
@@ -28718,7 +28748,7 @@
         <p:spPr>
           <a:xfrm>
             <a:off x="6629400" y="4270320"/>
-            <a:ext cx="1415160" cy="182160"/>
+            <a:ext cx="1414800" cy="182160"/>
           </a:xfrm>
           <a:prstGeom prst="rect">
             <a:avLst/>
@@ -28770,7 +28800,7 @@
         <p:spPr>
           <a:xfrm>
             <a:off x="8001000" y="4270320"/>
-            <a:ext cx="3472560" cy="190080"/>
+            <a:ext cx="3472200" cy="190080"/>
           </a:xfrm>
           <a:prstGeom prst="rect">
             <a:avLst/>
@@ -28822,7 +28852,7 @@
         <p:spPr>
           <a:xfrm>
             <a:off x="768240" y="5120640"/>
-            <a:ext cx="10650600" cy="592200"/>
+            <a:ext cx="10650240" cy="591840"/>
           </a:xfrm>
           <a:prstGeom prst="roundRect">
             <a:avLst>
@@ -28865,7 +28895,7 @@
         <p:spPr>
           <a:xfrm>
             <a:off x="768240" y="5120640"/>
-            <a:ext cx="48600" cy="592200"/>
+            <a:ext cx="48240" cy="591840"/>
           </a:xfrm>
           <a:prstGeom prst="rect">
             <a:avLst/>
@@ -28906,7 +28936,7 @@
         <p:spPr>
           <a:xfrm>
             <a:off x="1024200" y="5331600"/>
-            <a:ext cx="10193400" cy="207000"/>
+            <a:ext cx="10193040" cy="207000"/>
           </a:xfrm>
           <a:prstGeom prst="rect">
             <a:avLst/>
@@ -28995,7 +29025,7 @@
         <p:spPr>
           <a:xfrm>
             <a:off x="768240" y="420480"/>
-            <a:ext cx="10604880" cy="441360"/>
+            <a:ext cx="10604520" cy="441360"/>
           </a:xfrm>
           <a:prstGeom prst="rect">
             <a:avLst/>
@@ -29047,7 +29077,7 @@
         <p:spPr>
           <a:xfrm>
             <a:off x="768240" y="1170360"/>
-            <a:ext cx="1369440" cy="42120"/>
+            <a:ext cx="1369080" cy="41760"/>
           </a:xfrm>
           <a:prstGeom prst="rect">
             <a:avLst/>
@@ -29088,7 +29118,7 @@
         <p:spPr>
           <a:xfrm>
             <a:off x="768240" y="1298520"/>
-            <a:ext cx="10604880" cy="227880"/>
+            <a:ext cx="10604520" cy="227880"/>
           </a:xfrm>
           <a:prstGeom prst="rect">
             <a:avLst/>
@@ -29140,7 +29170,7 @@
         <p:spPr>
           <a:xfrm>
             <a:off x="0" y="6437520"/>
-            <a:ext cx="12189600" cy="12960"/>
+            <a:ext cx="12189240" cy="12600"/>
           </a:xfrm>
           <a:prstGeom prst="rect">
             <a:avLst/>
@@ -29181,7 +29211,7 @@
         <p:spPr>
           <a:xfrm>
             <a:off x="768240" y="6473880"/>
-            <a:ext cx="8227440" cy="136800"/>
+            <a:ext cx="8227080" cy="136800"/>
           </a:xfrm>
           <a:prstGeom prst="rect">
             <a:avLst/>
@@ -29233,7 +29263,7 @@
         <p:spPr>
           <a:xfrm>
             <a:off x="10607040" y="6473880"/>
-            <a:ext cx="820800" cy="136800"/>
+            <a:ext cx="820440" cy="136800"/>
           </a:xfrm>
           <a:prstGeom prst="rect">
             <a:avLst/>
@@ -29285,7 +29315,7 @@
         <p:spPr>
           <a:xfrm>
             <a:off x="768240" y="1828800"/>
-            <a:ext cx="5301360" cy="227880"/>
+            <a:ext cx="5301000" cy="227880"/>
           </a:xfrm>
           <a:prstGeom prst="rect">
             <a:avLst/>
@@ -29337,7 +29367,7 @@
         <p:spPr>
           <a:xfrm>
             <a:off x="768240" y="2286000"/>
-            <a:ext cx="5392800" cy="1692720"/>
+            <a:ext cx="5392440" cy="1692720"/>
           </a:xfrm>
           <a:prstGeom prst="rect">
             <a:avLst/>
@@ -29538,7 +29568,7 @@
         <p:spPr>
           <a:xfrm>
             <a:off x="6400800" y="1828800"/>
-            <a:ext cx="5027040" cy="1552320"/>
+            <a:ext cx="5026680" cy="1551960"/>
           </a:xfrm>
           <a:prstGeom prst="roundRect">
             <a:avLst>
@@ -29581,7 +29611,7 @@
         <p:spPr>
           <a:xfrm>
             <a:off x="6400800" y="1828800"/>
-            <a:ext cx="48600" cy="1552320"/>
+            <a:ext cx="48240" cy="1551960"/>
           </a:xfrm>
           <a:prstGeom prst="rect">
             <a:avLst/>
@@ -29622,7 +29652,7 @@
         <p:spPr>
           <a:xfrm>
             <a:off x="6656760" y="2304360"/>
-            <a:ext cx="4569840" cy="638280"/>
+            <a:ext cx="4569480" cy="638280"/>
           </a:xfrm>
           <a:prstGeom prst="rect">
             <a:avLst/>
@@ -29705,7 +29735,7 @@
         <p:spPr>
           <a:xfrm>
             <a:off x="6400800" y="3566160"/>
-            <a:ext cx="5027040" cy="1506600"/>
+            <a:ext cx="5026680" cy="1506240"/>
           </a:xfrm>
           <a:prstGeom prst="roundRect">
             <a:avLst>
@@ -29748,7 +29778,7 @@
         <p:spPr>
           <a:xfrm>
             <a:off x="6400800" y="3566160"/>
-            <a:ext cx="48600" cy="1506600"/>
+            <a:ext cx="48240" cy="1506240"/>
           </a:xfrm>
           <a:prstGeom prst="rect">
             <a:avLst/>
@@ -29789,7 +29819,7 @@
         <p:spPr>
           <a:xfrm>
             <a:off x="6656760" y="3915000"/>
-            <a:ext cx="4569840" cy="846000"/>
+            <a:ext cx="4569480" cy="846000"/>
           </a:xfrm>
           <a:prstGeom prst="rect">
             <a:avLst/>
@@ -29876,7 +29906,7 @@
         <p:spPr>
           <a:xfrm>
             <a:off x="144000" y="4077720"/>
-            <a:ext cx="3036600" cy="1897200"/>
+            <a:ext cx="3036240" cy="1896840"/>
           </a:xfrm>
           <a:prstGeom prst="rect">
             <a:avLst/>
@@ -29899,7 +29929,7 @@
         <p:spPr>
           <a:xfrm>
             <a:off x="3384000" y="4176000"/>
-            <a:ext cx="2922120" cy="1825560"/>
+            <a:ext cx="2921760" cy="1825200"/>
           </a:xfrm>
           <a:prstGeom prst="rect">
             <a:avLst/>
@@ -29918,7 +29948,7 @@
         <p:spPr>
           <a:xfrm>
             <a:off x="864000" y="5976000"/>
-            <a:ext cx="1726920" cy="136800"/>
+            <a:ext cx="1726560" cy="136800"/>
           </a:xfrm>
           <a:prstGeom prst="rect">
             <a:avLst/>
@@ -29970,7 +30000,7 @@
         <p:spPr>
           <a:xfrm>
             <a:off x="3816000" y="6002640"/>
-            <a:ext cx="1726920" cy="273960"/>
+            <a:ext cx="1726560" cy="273960"/>
           </a:xfrm>
           <a:prstGeom prst="rect">
             <a:avLst/>
@@ -30059,7 +30089,7 @@
         <p:spPr>
           <a:xfrm>
             <a:off x="768240" y="420480"/>
-            <a:ext cx="10604880" cy="441360"/>
+            <a:ext cx="10604520" cy="441360"/>
           </a:xfrm>
           <a:prstGeom prst="rect">
             <a:avLst/>
@@ -30111,7 +30141,7 @@
         <p:spPr>
           <a:xfrm>
             <a:off x="768240" y="1170360"/>
-            <a:ext cx="1369440" cy="42120"/>
+            <a:ext cx="1369080" cy="41760"/>
           </a:xfrm>
           <a:prstGeom prst="rect">
             <a:avLst/>
@@ -30152,7 +30182,7 @@
         <p:spPr>
           <a:xfrm>
             <a:off x="768240" y="1298520"/>
-            <a:ext cx="10604880" cy="227880"/>
+            <a:ext cx="10604520" cy="227880"/>
           </a:xfrm>
           <a:prstGeom prst="rect">
             <a:avLst/>
@@ -30204,7 +30234,7 @@
         <p:spPr>
           <a:xfrm>
             <a:off x="0" y="6437520"/>
-            <a:ext cx="12189600" cy="12960"/>
+            <a:ext cx="12189240" cy="12600"/>
           </a:xfrm>
           <a:prstGeom prst="rect">
             <a:avLst/>
@@ -30245,7 +30275,7 @@
         <p:spPr>
           <a:xfrm>
             <a:off x="768240" y="6473880"/>
-            <a:ext cx="8227440" cy="136800"/>
+            <a:ext cx="8227080" cy="136800"/>
           </a:xfrm>
           <a:prstGeom prst="rect">
             <a:avLst/>
@@ -30297,7 +30327,7 @@
         <p:spPr>
           <a:xfrm>
             <a:off x="10607040" y="6473880"/>
-            <a:ext cx="820800" cy="136800"/>
+            <a:ext cx="820440" cy="136800"/>
           </a:xfrm>
           <a:prstGeom prst="rect">
             <a:avLst/>
@@ -30349,7 +30379,7 @@
         <p:spPr>
           <a:xfrm>
             <a:off x="768240" y="1828800"/>
-            <a:ext cx="5118480" cy="227880"/>
+            <a:ext cx="5118120" cy="227880"/>
           </a:xfrm>
           <a:prstGeom prst="rect">
             <a:avLst/>
@@ -30401,7 +30431,7 @@
         <p:spPr>
           <a:xfrm>
             <a:off x="768240" y="2286000"/>
-            <a:ext cx="5301360" cy="1823760"/>
+            <a:ext cx="5301000" cy="1823760"/>
           </a:xfrm>
           <a:prstGeom prst="rect">
             <a:avLst/>
@@ -30602,7 +30632,7 @@
         <p:spPr>
           <a:xfrm>
             <a:off x="6400800" y="1828800"/>
-            <a:ext cx="5027040" cy="227880"/>
+            <a:ext cx="5026680" cy="227880"/>
           </a:xfrm>
           <a:prstGeom prst="rect">
             <a:avLst/>
@@ -30654,7 +30684,7 @@
         <p:spPr>
           <a:xfrm>
             <a:off x="6400800" y="2286000"/>
-            <a:ext cx="5027040" cy="1823760"/>
+            <a:ext cx="5026680" cy="1823760"/>
           </a:xfrm>
           <a:prstGeom prst="rect">
             <a:avLst/>
@@ -30855,7 +30885,7 @@
         <p:spPr>
           <a:xfrm>
             <a:off x="768240" y="5074920"/>
-            <a:ext cx="10650600" cy="866520"/>
+            <a:ext cx="10650240" cy="866160"/>
           </a:xfrm>
           <a:prstGeom prst="roundRect">
             <a:avLst>
@@ -30898,7 +30928,7 @@
         <p:spPr>
           <a:xfrm>
             <a:off x="768240" y="5074920"/>
-            <a:ext cx="48600" cy="866520"/>
+            <a:ext cx="48240" cy="866160"/>
           </a:xfrm>
           <a:prstGeom prst="rect">
             <a:avLst/>
@@ -30939,7 +30969,7 @@
         <p:spPr>
           <a:xfrm>
             <a:off x="1024200" y="5311440"/>
-            <a:ext cx="10193400" cy="430560"/>
+            <a:ext cx="10193040" cy="430560"/>
           </a:xfrm>
           <a:prstGeom prst="rect">
             <a:avLst/>
@@ -31069,7 +31099,7 @@
         <p:spPr>
           <a:xfrm>
             <a:off x="768240" y="420480"/>
-            <a:ext cx="10604880" cy="441360"/>
+            <a:ext cx="10604520" cy="441360"/>
           </a:xfrm>
           <a:prstGeom prst="rect">
             <a:avLst/>
@@ -31121,7 +31151,7 @@
         <p:spPr>
           <a:xfrm>
             <a:off x="768240" y="1170360"/>
-            <a:ext cx="1369440" cy="42120"/>
+            <a:ext cx="1369080" cy="41760"/>
           </a:xfrm>
           <a:prstGeom prst="rect">
             <a:avLst/>
@@ -31162,7 +31192,7 @@
         <p:spPr>
           <a:xfrm>
             <a:off x="768240" y="1298520"/>
-            <a:ext cx="10604880" cy="227880"/>
+            <a:ext cx="10604520" cy="227880"/>
           </a:xfrm>
           <a:prstGeom prst="rect">
             <a:avLst/>
@@ -31214,7 +31244,7 @@
         <p:spPr>
           <a:xfrm>
             <a:off x="0" y="6437520"/>
-            <a:ext cx="12189600" cy="12960"/>
+            <a:ext cx="12189240" cy="12600"/>
           </a:xfrm>
           <a:prstGeom prst="rect">
             <a:avLst/>
@@ -31255,7 +31285,7 @@
         <p:spPr>
           <a:xfrm>
             <a:off x="768240" y="6473880"/>
-            <a:ext cx="8227440" cy="136800"/>
+            <a:ext cx="8227080" cy="136800"/>
           </a:xfrm>
           <a:prstGeom prst="rect">
             <a:avLst/>
@@ -31307,7 +31337,7 @@
         <p:spPr>
           <a:xfrm>
             <a:off x="10607040" y="6473880"/>
-            <a:ext cx="820800" cy="136800"/>
+            <a:ext cx="820440" cy="136800"/>
           </a:xfrm>
           <a:prstGeom prst="rect">
             <a:avLst/>
@@ -31359,7 +31389,7 @@
         <p:spPr>
           <a:xfrm>
             <a:off x="768240" y="1828800"/>
-            <a:ext cx="5392800" cy="1692720"/>
+            <a:ext cx="5392440" cy="1692720"/>
           </a:xfrm>
           <a:prstGeom prst="rect">
             <a:avLst/>
@@ -31560,7 +31590,7 @@
         <p:spPr>
           <a:xfrm>
             <a:off x="6400800" y="1737360"/>
-            <a:ext cx="5027040" cy="212760"/>
+            <a:ext cx="5026680" cy="212760"/>
           </a:xfrm>
           <a:prstGeom prst="rect">
             <a:avLst/>
@@ -31612,7 +31642,7 @@
         <p:spPr>
           <a:xfrm>
             <a:off x="6400800" y="2076840"/>
-            <a:ext cx="5027040" cy="1794600"/>
+            <a:ext cx="5026680" cy="1794240"/>
           </a:xfrm>
           <a:prstGeom prst="roundRect">
             <a:avLst>
@@ -31833,7 +31863,7 @@
         <p:spPr>
           <a:xfrm>
             <a:off x="5328000" y="5112720"/>
-            <a:ext cx="1150920" cy="214920"/>
+            <a:ext cx="1150560" cy="214560"/>
           </a:xfrm>
           <a:custGeom>
             <a:avLst/>
@@ -31902,7 +31932,7 @@
         <p:spPr>
           <a:xfrm>
             <a:off x="1152000" y="4005000"/>
-            <a:ext cx="3815640" cy="2384280"/>
+            <a:ext cx="3815280" cy="2383920"/>
           </a:xfrm>
           <a:prstGeom prst="rect">
             <a:avLst/>
@@ -31925,7 +31955,7 @@
         <p:spPr>
           <a:xfrm>
             <a:off x="6984000" y="4023000"/>
-            <a:ext cx="3815640" cy="2384640"/>
+            <a:ext cx="3815280" cy="2384280"/>
           </a:xfrm>
           <a:prstGeom prst="rect">
             <a:avLst/>
@@ -31981,7 +32011,7 @@
         <p:spPr>
           <a:xfrm>
             <a:off x="768240" y="420480"/>
-            <a:ext cx="10604880" cy="441360"/>
+            <a:ext cx="10604520" cy="441360"/>
           </a:xfrm>
           <a:prstGeom prst="rect">
             <a:avLst/>
@@ -32033,7 +32063,7 @@
         <p:spPr>
           <a:xfrm>
             <a:off x="768240" y="1170360"/>
-            <a:ext cx="1369440" cy="42120"/>
+            <a:ext cx="1369080" cy="41760"/>
           </a:xfrm>
           <a:prstGeom prst="rect">
             <a:avLst/>
@@ -32074,7 +32104,7 @@
         <p:spPr>
           <a:xfrm>
             <a:off x="768240" y="1298520"/>
-            <a:ext cx="10604880" cy="227880"/>
+            <a:ext cx="10604520" cy="227880"/>
           </a:xfrm>
           <a:prstGeom prst="rect">
             <a:avLst/>
@@ -32126,7 +32156,7 @@
         <p:spPr>
           <a:xfrm>
             <a:off x="0" y="6437520"/>
-            <a:ext cx="12189600" cy="12960"/>
+            <a:ext cx="12189240" cy="12600"/>
           </a:xfrm>
           <a:prstGeom prst="rect">
             <a:avLst/>
@@ -32167,7 +32197,7 @@
         <p:spPr>
           <a:xfrm>
             <a:off x="768240" y="6473880"/>
-            <a:ext cx="8227440" cy="136800"/>
+            <a:ext cx="8227080" cy="136800"/>
           </a:xfrm>
           <a:prstGeom prst="rect">
             <a:avLst/>
@@ -32219,7 +32249,7 @@
         <p:spPr>
           <a:xfrm>
             <a:off x="10607040" y="6473880"/>
-            <a:ext cx="820800" cy="136800"/>
+            <a:ext cx="820440" cy="136800"/>
           </a:xfrm>
           <a:prstGeom prst="rect">
             <a:avLst/>
@@ -32271,7 +32301,7 @@
         <p:spPr>
           <a:xfrm>
             <a:off x="768240" y="1828800"/>
-            <a:ext cx="5392800" cy="227880"/>
+            <a:ext cx="5392440" cy="227880"/>
           </a:xfrm>
           <a:prstGeom prst="rect">
             <a:avLst/>
@@ -32323,7 +32353,7 @@
         <p:spPr>
           <a:xfrm>
             <a:off x="768240" y="2286000"/>
-            <a:ext cx="5484240" cy="1692720"/>
+            <a:ext cx="5483880" cy="1692720"/>
           </a:xfrm>
           <a:prstGeom prst="rect">
             <a:avLst/>
@@ -32524,7 +32554,7 @@
         <p:spPr>
           <a:xfrm>
             <a:off x="6446520" y="1828800"/>
-            <a:ext cx="4981320" cy="2100960"/>
+            <a:ext cx="4980960" cy="2100600"/>
           </a:xfrm>
           <a:prstGeom prst="roundRect">
             <a:avLst>
@@ -32567,7 +32597,7 @@
         <p:spPr>
           <a:xfrm>
             <a:off x="6446520" y="1828800"/>
-            <a:ext cx="48600" cy="2100960"/>
+            <a:ext cx="48240" cy="2100600"/>
           </a:xfrm>
           <a:prstGeom prst="rect">
             <a:avLst/>
@@ -32608,7 +32638,7 @@
         <p:spPr>
           <a:xfrm>
             <a:off x="6702480" y="2267640"/>
-            <a:ext cx="4524120" cy="1261440"/>
+            <a:ext cx="4523760" cy="1261440"/>
           </a:xfrm>
           <a:prstGeom prst="rect">
             <a:avLst/>
@@ -32747,7 +32777,7 @@
         <p:spPr>
           <a:xfrm>
             <a:off x="1199520" y="3960360"/>
-            <a:ext cx="3191760" cy="2462400"/>
+            <a:ext cx="3191400" cy="2462040"/>
           </a:xfrm>
           <a:prstGeom prst="rect">
             <a:avLst/>
@@ -32770,7 +32800,7 @@
         <p:spPr>
           <a:xfrm>
             <a:off x="6050880" y="3972240"/>
-            <a:ext cx="3164400" cy="2441160"/>
+            <a:ext cx="3164040" cy="2440800"/>
           </a:xfrm>
           <a:prstGeom prst="rect">
             <a:avLst/>
@@ -32789,7 +32819,7 @@
         <p:spPr>
           <a:xfrm>
             <a:off x="4608360" y="5184360"/>
-            <a:ext cx="1150920" cy="214920"/>
+            <a:ext cx="1150560" cy="214560"/>
           </a:xfrm>
           <a:custGeom>
             <a:avLst/>

</xml_diff>